<commit_message>
Make output/ the sole PP Research Detailed v2 deck.
Document that copies under ppt/pp and pp-extrapolation are not kept; builders write only here.

Co-authored-by: Cursor <cursoragent@cursor.com>
</commit_message>
<xml_diff>
--- a/output/PP_Research_Detailed_v2.pptx
+++ b/output/PP_Research_Detailed_v2.pptx
@@ -35467,7 +35467,7 @@
                 <a:latin typeface="AppleGothic"/>
                 <a:ea typeface="AppleGothic"/>
               </a:rPr>
-              <a:t>ppt/pp/PP_Research_Detailed_v2.pptx</a:t>
+              <a:t>pp_pae_total/output/PP_Research_Detailed_v2.pptx</a:t>
             </a:r>
           </a:p>
         </p:txBody>
@@ -69006,7 +69006,7 @@
                 <a:latin typeface="AppleGothic"/>
                 <a:ea typeface="AppleGothic"/>
               </a:rPr>
-              <a:t>고정본 파일: ppt/pp/PP_Research_Detailed_v2.pptx</a:t>
+              <a:t>고정본(단일): pp_pae_total/output/PP_Research_Detailed_v2.pptx</a:t>
             </a:r>
           </a:p>
           <a:p>

</xml_diff>

<commit_message>
Put TabPFN in the main competitor figure with the other methods.
Drop the separate TabPFN slide and the 'auxiliary' framing; show heatmap plus grouped bars on one comparison page.

Co-authored-by: Cursor <cursoragent@cursor.com>
</commit_message>
<xml_diff>
--- a/output/PP_Research_Detailed_v2.pptx
+++ b/output/PP_Research_Detailed_v2.pptx
@@ -16,7 +16,6 @@
     <p:sldId id="264" r:id="rId15"/>
     <p:sldId id="265" r:id="rId16"/>
     <p:sldId id="266" r:id="rId17"/>
-    <p:sldId id="267" r:id="rId18"/>
   </p:sldIdLst>
   <p:sldSz cx="12192000" cy="6858000" type="screen4x3"/>
   <p:notesSz cx="6858000" cy="9144000"/>
@@ -3524,7 +3523,7 @@
                 <a:latin typeface="AppleGothic"/>
                 <a:ea typeface="AppleGothic"/>
               </a:rPr>
-              <a:t>안정성</a:t>
+              <a:t>실패 · 경계</a:t>
             </a:r>
           </a:p>
         </p:txBody>
@@ -3560,14 +3559,14 @@
                 <a:latin typeface="AppleGothic"/>
                 <a:ea typeface="AppleGothic"/>
               </a:rPr>
-              <a:t>bootstrap CI  ·  MICH unit $R^2$</a:t>
+              <a:t>표로 남긴 한계  ·  주장 / 비주장</a:t>
             </a:r>
           </a:p>
         </p:txBody>
       </p:sp>
       <p:pic>
         <p:nvPicPr>
-          <p:cNvPr id="6" name="Picture 5" descr="robustness_panel.png"/>
+          <p:cNvPr id="6" name="Picture 5" descr="fail_cases.png"/>
           <p:cNvPicPr>
             <a:picLocks noChangeAspect="1"/>
           </p:cNvPicPr>
@@ -3581,8 +3580,32 @@
         </p:blipFill>
         <p:spPr>
           <a:xfrm>
-            <a:off x="285750" y="857250"/>
-            <a:ext cx="11620500" cy="5048250"/>
+            <a:off x="285750" y="809625"/>
+            <a:ext cx="5905500" cy="4953000"/>
+          </a:xfrm>
+          <a:prstGeom prst="rect">
+            <a:avLst/>
+          </a:prstGeom>
+        </p:spPr>
+      </p:pic>
+      <p:pic>
+        <p:nvPicPr>
+          <p:cNvPr id="7" name="Picture 6" descr="status_compact.png"/>
+          <p:cNvPicPr>
+            <a:picLocks noChangeAspect="1"/>
+          </p:cNvPicPr>
+          <p:nvPr/>
+        </p:nvPicPr>
+        <p:blipFill>
+          <a:blip r:embed="rId3"/>
+          <a:stretch>
+            <a:fillRect/>
+          </a:stretch>
+        </p:blipFill>
+        <p:spPr>
+          <a:xfrm>
+            <a:off x="6286500" y="809625"/>
+            <a:ext cx="5334000" cy="4953000"/>
           </a:xfrm>
           <a:prstGeom prst="rect">
             <a:avLst/>
@@ -3591,7 +3614,7 @@
       </p:pic>
       <p:cxnSp>
         <p:nvCxnSpPr>
-          <p:cNvPr id="7" name="Connector 6"/>
+          <p:cNvPr id="8" name="Connector 7"/>
           <p:cNvCxnSpPr/>
           <p:nvPr/>
         </p:nvCxnSpPr>
@@ -3626,7 +3649,7 @@
       </p:cxnSp>
       <p:sp>
         <p:nvSpPr>
-          <p:cNvPr id="8" name="TextBox 7"/>
+          <p:cNvPr id="9" name="TextBox 8"/>
           <p:cNvSpPr txBox="1"/>
           <p:nvPr/>
         </p:nvSpPr>
@@ -3662,7 +3685,7 @@
       </p:sp>
       <p:sp>
         <p:nvSpPr>
-          <p:cNvPr id="9" name="TextBox 8"/>
+          <p:cNvPr id="10" name="TextBox 9"/>
           <p:cNvSpPr txBox="1"/>
           <p:nvPr/>
         </p:nvSpPr>
@@ -3691,7 +3714,7 @@
                 <a:latin typeface="AppleGothic"/>
                 <a:ea typeface="AppleGothic"/>
               </a:rPr>
-              <a:t>10/12</a:t>
+              <a:t>10/11</a:t>
             </a:r>
           </a:p>
         </p:txBody>
@@ -3831,7 +3854,7 @@
                 <a:latin typeface="AppleGothic"/>
                 <a:ea typeface="AppleGothic"/>
               </a:rPr>
-              <a:t>실패 · 경계</a:t>
+              <a:t>경로와 한 줄</a:t>
             </a:r>
           </a:p>
         </p:txBody>
@@ -3867,14 +3890,14 @@
                 <a:latin typeface="AppleGothic"/>
                 <a:ea typeface="AppleGothic"/>
               </a:rPr>
-              <a:t>표로 남긴 한계  ·  주장 / 비주장</a:t>
+              <a:t>PAE / SAAR  ·  오늘 가져갈 말</a:t>
             </a:r>
           </a:p>
         </p:txBody>
       </p:sp>
       <p:pic>
         <p:nvPicPr>
-          <p:cNvPr id="6" name="Picture 5" descr="fail_cases.png"/>
+          <p:cNvPr id="6" name="Picture 5" descr="pp_vs_pae_split.png"/>
           <p:cNvPicPr>
             <a:picLocks noChangeAspect="1"/>
           </p:cNvPicPr>
@@ -3888,41 +3911,125 @@
         </p:blipFill>
         <p:spPr>
           <a:xfrm>
-            <a:off x="285750" y="809625"/>
-            <a:ext cx="5905500" cy="4953000"/>
+            <a:off x="381000" y="809625"/>
+            <a:ext cx="11430000" cy="3619500"/>
           </a:xfrm>
           <a:prstGeom prst="rect">
             <a:avLst/>
           </a:prstGeom>
         </p:spPr>
       </p:pic>
-      <p:pic>
-        <p:nvPicPr>
-          <p:cNvPr id="7" name="Picture 6" descr="status_compact.png"/>
-          <p:cNvPicPr>
-            <a:picLocks noChangeAspect="1"/>
-          </p:cNvPicPr>
-          <p:nvPr/>
-        </p:nvPicPr>
-        <p:blipFill>
-          <a:blip r:embed="rId3"/>
-          <a:stretch>
-            <a:fillRect/>
-          </a:stretch>
-        </p:blipFill>
-        <p:spPr>
-          <a:xfrm>
-            <a:off x="6286500" y="809625"/>
-            <a:ext cx="5334000" cy="4953000"/>
-          </a:xfrm>
-          <a:prstGeom prst="rect">
-            <a:avLst/>
-          </a:prstGeom>
-        </p:spPr>
-      </p:pic>
+      <p:sp>
+        <p:nvSpPr>
+          <p:cNvPr id="7" name="TextBox 6"/>
+          <p:cNvSpPr txBox="1"/>
+          <p:nvPr/>
+        </p:nvSpPr>
+        <p:spPr>
+          <a:xfrm>
+            <a:off x="533400" y="4667250"/>
+            <a:ext cx="11049000" cy="266700"/>
+          </a:xfrm>
+          <a:prstGeom prst="rect">
+            <a:avLst/>
+          </a:prstGeom>
+          <a:noFill/>
+        </p:spPr>
+        <p:txBody>
+          <a:bodyPr wrap="square">
+            <a:spAutoFit/>
+          </a:bodyPr>
+          <a:lstStyle/>
+          <a:p>
+            <a:pPr algn="l"/>
+            <a:r>
+              <a:rPr sz="1400" b="0">
+                <a:solidFill>
+                  <a:srgbClr val="111111"/>
+                </a:solidFill>
+                <a:latin typeface="AppleGothic"/>
+                <a:ea typeface="AppleGothic"/>
+              </a:rPr>
+              <a:t>1  밖을 지탱하는 것은 가정이지만, 식만 넣으면 답이 아니다.</a:t>
+            </a:r>
+          </a:p>
+        </p:txBody>
+      </p:sp>
+      <p:sp>
+        <p:nvSpPr>
+          <p:cNvPr id="8" name="TextBox 7"/>
+          <p:cNvSpPr txBox="1"/>
+          <p:nvPr/>
+        </p:nvSpPr>
+        <p:spPr>
+          <a:xfrm>
+            <a:off x="533400" y="5048250"/>
+            <a:ext cx="11049000" cy="266700"/>
+          </a:xfrm>
+          <a:prstGeom prst="rect">
+            <a:avLst/>
+          </a:prstGeom>
+          <a:noFill/>
+        </p:spPr>
+        <p:txBody>
+          <a:bodyPr wrap="square">
+            <a:spAutoFit/>
+          </a:bodyPr>
+          <a:lstStyle/>
+          <a:p>
+            <a:pPr algn="l"/>
+            <a:r>
+              <a:rPr sz="1400" b="0">
+                <a:solidFill>
+                  <a:srgbClr val="111111"/>
+                </a:solidFill>
+                <a:latin typeface="AppleGothic"/>
+                <a:ea typeface="AppleGothic"/>
+              </a:rPr>
+              <a:t>2  식이 없으면 SAAR — 동결 affine + 제한 residual.  주표 0.934 / 0.842 / 0.751.</a:t>
+            </a:r>
+          </a:p>
+        </p:txBody>
+      </p:sp>
+      <p:sp>
+        <p:nvSpPr>
+          <p:cNvPr id="9" name="TextBox 8"/>
+          <p:cNvSpPr txBox="1"/>
+          <p:nvPr/>
+        </p:nvSpPr>
+        <p:spPr>
+          <a:xfrm>
+            <a:off x="533400" y="5429250"/>
+            <a:ext cx="11049000" cy="266700"/>
+          </a:xfrm>
+          <a:prstGeom prst="rect">
+            <a:avLst/>
+          </a:prstGeom>
+          <a:noFill/>
+        </p:spPr>
+        <p:txBody>
+          <a:bodyPr wrap="square">
+            <a:spAutoFit/>
+          </a:bodyPr>
+          <a:lstStyle/>
+          <a:p>
+            <a:pPr algn="l"/>
+            <a:r>
+              <a:rPr sz="1400" b="0">
+                <a:solidFill>
+                  <a:srgbClr val="111111"/>
+                </a:solidFill>
+                <a:latin typeface="AppleGothic"/>
+                <a:ea typeface="AppleGothic"/>
+              </a:rPr>
+              <a:t>3  실패·Zn·PAE는 한계/후속. 만능 SOTA를 주장하지 않는다.</a:t>
+            </a:r>
+          </a:p>
+        </p:txBody>
+      </p:sp>
       <p:cxnSp>
         <p:nvCxnSpPr>
-          <p:cNvPr id="8" name="Connector 7"/>
+          <p:cNvPr id="10" name="Connector 9"/>
           <p:cNvCxnSpPr/>
           <p:nvPr/>
         </p:nvCxnSpPr>
@@ -3957,7 +4064,7 @@
       </p:cxnSp>
       <p:sp>
         <p:nvSpPr>
-          <p:cNvPr id="9" name="TextBox 8"/>
+          <p:cNvPr id="11" name="TextBox 10"/>
           <p:cNvSpPr txBox="1"/>
           <p:nvPr/>
         </p:nvSpPr>
@@ -3993,7 +4100,7 @@
       </p:sp>
       <p:sp>
         <p:nvSpPr>
-          <p:cNvPr id="10" name="TextBox 9"/>
+          <p:cNvPr id="12" name="TextBox 11"/>
           <p:cNvSpPr txBox="1"/>
           <p:nvPr/>
         </p:nvSpPr>
@@ -4022,422 +4129,7 @@
                 <a:latin typeface="AppleGothic"/>
                 <a:ea typeface="AppleGothic"/>
               </a:rPr>
-              <a:t>11/12</a:t>
-            </a:r>
-          </a:p>
-        </p:txBody>
-      </p:sp>
-    </p:spTree>
-  </p:cSld>
-  <p:clrMapOvr>
-    <a:masterClrMapping/>
-  </p:clrMapOvr>
-</p:sld>
-</file>
-
-<file path=ppt/slides/slide12.xml><?xml version="1.0" encoding="utf-8"?>
-<p:sld xmlns:a="http://schemas.openxmlformats.org/drawingml/2006/main" xmlns:p="http://schemas.openxmlformats.org/presentationml/2006/main" xmlns:r="http://schemas.openxmlformats.org/officeDocument/2006/relationships">
-  <p:cSld>
-    <p:spTree>
-      <p:nvGrpSpPr>
-        <p:cNvPr id="1" name=""/>
-        <p:cNvGrpSpPr/>
-        <p:nvPr/>
-      </p:nvGrpSpPr>
-      <p:grpSpPr/>
-      <p:sp>
-        <p:nvSpPr>
-          <p:cNvPr id="2" name="Rectangle 1"/>
-          <p:cNvSpPr/>
-          <p:nvPr/>
-        </p:nvSpPr>
-        <p:spPr>
-          <a:xfrm>
-            <a:off x="0" y="0"/>
-            <a:ext cx="12192000" cy="6858000"/>
-          </a:xfrm>
-          <a:prstGeom prst="rect">
-            <a:avLst/>
-          </a:prstGeom>
-          <a:solidFill>
-            <a:srgbClr val="FFFFFF"/>
-          </a:solidFill>
-          <a:ln>
-            <a:noFill/>
-          </a:ln>
-        </p:spPr>
-        <p:style>
-          <a:lnRef idx="1">
-            <a:schemeClr val="accent1"/>
-          </a:lnRef>
-          <a:fillRef idx="3">
-            <a:schemeClr val="accent1"/>
-          </a:fillRef>
-          <a:effectRef idx="2">
-            <a:schemeClr val="accent1"/>
-          </a:effectRef>
-          <a:fontRef idx="minor">
-            <a:schemeClr val="lt1"/>
-          </a:fontRef>
-        </p:style>
-        <p:txBody>
-          <a:bodyPr rtlCol="0" anchor="ctr"/>
-          <a:lstStyle/>
-          <a:p>
-            <a:pPr algn="ctr"/>
-          </a:p>
-        </p:txBody>
-      </p:sp>
-      <p:sp>
-        <p:nvSpPr>
-          <p:cNvPr id="3" name="Rectangle 2"/>
-          <p:cNvSpPr/>
-          <p:nvPr/>
-        </p:nvSpPr>
-        <p:spPr>
-          <a:xfrm>
-            <a:off x="0" y="0"/>
-            <a:ext cx="12192000" cy="38100"/>
-          </a:xfrm>
-          <a:prstGeom prst="rect">
-            <a:avLst/>
-          </a:prstGeom>
-          <a:solidFill>
-            <a:srgbClr val="0A5C5C"/>
-          </a:solidFill>
-          <a:ln>
-            <a:noFill/>
-          </a:ln>
-        </p:spPr>
-        <p:style>
-          <a:lnRef idx="1">
-            <a:schemeClr val="accent1"/>
-          </a:lnRef>
-          <a:fillRef idx="3">
-            <a:schemeClr val="accent1"/>
-          </a:fillRef>
-          <a:effectRef idx="2">
-            <a:schemeClr val="accent1"/>
-          </a:effectRef>
-          <a:fontRef idx="minor">
-            <a:schemeClr val="lt1"/>
-          </a:fontRef>
-        </p:style>
-        <p:txBody>
-          <a:bodyPr rtlCol="0" anchor="ctr"/>
-          <a:lstStyle/>
-          <a:p>
-            <a:pPr algn="ctr"/>
-          </a:p>
-        </p:txBody>
-      </p:sp>
-      <p:sp>
-        <p:nvSpPr>
-          <p:cNvPr id="4" name="TextBox 3"/>
-          <p:cNvSpPr txBox="1"/>
-          <p:nvPr/>
-        </p:nvSpPr>
-        <p:spPr>
-          <a:xfrm>
-            <a:off x="457200" y="209550"/>
-            <a:ext cx="11239500" cy="323850"/>
-          </a:xfrm>
-          <a:prstGeom prst="rect">
-            <a:avLst/>
-          </a:prstGeom>
-          <a:noFill/>
-        </p:spPr>
-        <p:txBody>
-          <a:bodyPr wrap="square">
-            <a:spAutoFit/>
-          </a:bodyPr>
-          <a:lstStyle/>
-          <a:p>
-            <a:pPr algn="l"/>
-            <a:r>
-              <a:rPr sz="2200" b="1">
-                <a:solidFill>
-                  <a:srgbClr val="111111"/>
-                </a:solidFill>
-                <a:latin typeface="AppleGothic"/>
-                <a:ea typeface="AppleGothic"/>
-              </a:rPr>
-              <a:t>경로와 한 줄</a:t>
-            </a:r>
-          </a:p>
-        </p:txBody>
-      </p:sp>
-      <p:sp>
-        <p:nvSpPr>
-          <p:cNvPr id="5" name="TextBox 4"/>
-          <p:cNvSpPr txBox="1"/>
-          <p:nvPr/>
-        </p:nvSpPr>
-        <p:spPr>
-          <a:xfrm>
-            <a:off x="457200" y="533400"/>
-            <a:ext cx="11239500" cy="190500"/>
-          </a:xfrm>
-          <a:prstGeom prst="rect">
-            <a:avLst/>
-          </a:prstGeom>
-          <a:noFill/>
-        </p:spPr>
-        <p:txBody>
-          <a:bodyPr wrap="square">
-            <a:spAutoFit/>
-          </a:bodyPr>
-          <a:lstStyle/>
-          <a:p>
-            <a:pPr algn="l"/>
-            <a:r>
-              <a:rPr sz="1200" b="0">
-                <a:solidFill>
-                  <a:srgbClr val="555555"/>
-                </a:solidFill>
-                <a:latin typeface="AppleGothic"/>
-                <a:ea typeface="AppleGothic"/>
-              </a:rPr>
-              <a:t>PAE / SAAR  ·  오늘 가져갈 말</a:t>
-            </a:r>
-          </a:p>
-        </p:txBody>
-      </p:sp>
-      <p:pic>
-        <p:nvPicPr>
-          <p:cNvPr id="6" name="Picture 5" descr="pp_vs_pae_split.png"/>
-          <p:cNvPicPr>
-            <a:picLocks noChangeAspect="1"/>
-          </p:cNvPicPr>
-          <p:nvPr/>
-        </p:nvPicPr>
-        <p:blipFill>
-          <a:blip r:embed="rId2"/>
-          <a:stretch>
-            <a:fillRect/>
-          </a:stretch>
-        </p:blipFill>
-        <p:spPr>
-          <a:xfrm>
-            <a:off x="381000" y="809625"/>
-            <a:ext cx="11430000" cy="3619500"/>
-          </a:xfrm>
-          <a:prstGeom prst="rect">
-            <a:avLst/>
-          </a:prstGeom>
-        </p:spPr>
-      </p:pic>
-      <p:sp>
-        <p:nvSpPr>
-          <p:cNvPr id="7" name="TextBox 6"/>
-          <p:cNvSpPr txBox="1"/>
-          <p:nvPr/>
-        </p:nvSpPr>
-        <p:spPr>
-          <a:xfrm>
-            <a:off x="533400" y="4667250"/>
-            <a:ext cx="11049000" cy="266700"/>
-          </a:xfrm>
-          <a:prstGeom prst="rect">
-            <a:avLst/>
-          </a:prstGeom>
-          <a:noFill/>
-        </p:spPr>
-        <p:txBody>
-          <a:bodyPr wrap="square">
-            <a:spAutoFit/>
-          </a:bodyPr>
-          <a:lstStyle/>
-          <a:p>
-            <a:pPr algn="l"/>
-            <a:r>
-              <a:rPr sz="1400" b="0">
-                <a:solidFill>
-                  <a:srgbClr val="111111"/>
-                </a:solidFill>
-                <a:latin typeface="AppleGothic"/>
-                <a:ea typeface="AppleGothic"/>
-              </a:rPr>
-              <a:t>1  밖을 지탱하는 것은 가정이지만, 식만 넣으면 답이 아니다.</a:t>
-            </a:r>
-          </a:p>
-        </p:txBody>
-      </p:sp>
-      <p:sp>
-        <p:nvSpPr>
-          <p:cNvPr id="8" name="TextBox 7"/>
-          <p:cNvSpPr txBox="1"/>
-          <p:nvPr/>
-        </p:nvSpPr>
-        <p:spPr>
-          <a:xfrm>
-            <a:off x="533400" y="5048250"/>
-            <a:ext cx="11049000" cy="266700"/>
-          </a:xfrm>
-          <a:prstGeom prst="rect">
-            <a:avLst/>
-          </a:prstGeom>
-          <a:noFill/>
-        </p:spPr>
-        <p:txBody>
-          <a:bodyPr wrap="square">
-            <a:spAutoFit/>
-          </a:bodyPr>
-          <a:lstStyle/>
-          <a:p>
-            <a:pPr algn="l"/>
-            <a:r>
-              <a:rPr sz="1400" b="0">
-                <a:solidFill>
-                  <a:srgbClr val="111111"/>
-                </a:solidFill>
-                <a:latin typeface="AppleGothic"/>
-                <a:ea typeface="AppleGothic"/>
-              </a:rPr>
-              <a:t>2  식이 없으면 SAAR — 동결 affine + 제한 residual.  주표 0.934 / 0.842 / 0.751.</a:t>
-            </a:r>
-          </a:p>
-        </p:txBody>
-      </p:sp>
-      <p:sp>
-        <p:nvSpPr>
-          <p:cNvPr id="9" name="TextBox 8"/>
-          <p:cNvSpPr txBox="1"/>
-          <p:nvPr/>
-        </p:nvSpPr>
-        <p:spPr>
-          <a:xfrm>
-            <a:off x="533400" y="5429250"/>
-            <a:ext cx="11049000" cy="266700"/>
-          </a:xfrm>
-          <a:prstGeom prst="rect">
-            <a:avLst/>
-          </a:prstGeom>
-          <a:noFill/>
-        </p:spPr>
-        <p:txBody>
-          <a:bodyPr wrap="square">
-            <a:spAutoFit/>
-          </a:bodyPr>
-          <a:lstStyle/>
-          <a:p>
-            <a:pPr algn="l"/>
-            <a:r>
-              <a:rPr sz="1400" b="0">
-                <a:solidFill>
-                  <a:srgbClr val="111111"/>
-                </a:solidFill>
-                <a:latin typeface="AppleGothic"/>
-                <a:ea typeface="AppleGothic"/>
-              </a:rPr>
-              <a:t>3  실패·Zn·PAE는 한계/후속. 만능 SOTA를 주장하지 않는다.</a:t>
-            </a:r>
-          </a:p>
-        </p:txBody>
-      </p:sp>
-      <p:cxnSp>
-        <p:nvCxnSpPr>
-          <p:cNvPr id="10" name="Connector 9"/>
-          <p:cNvCxnSpPr/>
-          <p:nvPr/>
-        </p:nvCxnSpPr>
-        <p:spPr>
-          <a:xfrm>
-            <a:off x="457200" y="6477000"/>
-            <a:ext cx="11277600" cy="0"/>
-          </a:xfrm>
-          <a:prstGeom prst="line">
-            <a:avLst/>
-          </a:prstGeom>
-          <a:ln w="9525">
-            <a:solidFill>
-              <a:srgbClr val="D0D0D0"/>
-            </a:solidFill>
-          </a:ln>
-        </p:spPr>
-        <p:style>
-          <a:lnRef idx="2">
-            <a:schemeClr val="accent1"/>
-          </a:lnRef>
-          <a:fillRef idx="0">
-            <a:schemeClr val="accent1"/>
-          </a:fillRef>
-          <a:effectRef idx="1">
-            <a:schemeClr val="accent1"/>
-          </a:effectRef>
-          <a:fontRef idx="minor">
-            <a:schemeClr val="tx1"/>
-          </a:fontRef>
-        </p:style>
-      </p:cxnSp>
-      <p:sp>
-        <p:nvSpPr>
-          <p:cNvPr id="11" name="TextBox 10"/>
-          <p:cNvSpPr txBox="1"/>
-          <p:nvPr/>
-        </p:nvSpPr>
-        <p:spPr>
-          <a:xfrm>
-            <a:off x="457200" y="6534150"/>
-            <a:ext cx="7620000" cy="133350"/>
-          </a:xfrm>
-          <a:prstGeom prst="rect">
-            <a:avLst/>
-          </a:prstGeom>
-          <a:noFill/>
-        </p:spPr>
-        <p:txBody>
-          <a:bodyPr wrap="square">
-            <a:spAutoFit/>
-          </a:bodyPr>
-          <a:lstStyle/>
-          <a:p>
-            <a:pPr algn="l"/>
-            <a:r>
-              <a:rPr sz="900" b="0">
-                <a:solidFill>
-                  <a:srgbClr val="555555"/>
-                </a:solidFill>
-                <a:latin typeface="AppleGothic"/>
-                <a:ea typeface="AppleGothic"/>
-              </a:rPr>
-              <a:t>SPS Lab  ·  Assumption-Aware Extrapolation  ·  SAAR</a:t>
-            </a:r>
-          </a:p>
-        </p:txBody>
-      </p:sp>
-      <p:sp>
-        <p:nvSpPr>
-          <p:cNvPr id="12" name="TextBox 11"/>
-          <p:cNvSpPr txBox="1"/>
-          <p:nvPr/>
-        </p:nvSpPr>
-        <p:spPr>
-          <a:xfrm>
-            <a:off x="10477500" y="6515100"/>
-            <a:ext cx="952500" cy="152400"/>
-          </a:xfrm>
-          <a:prstGeom prst="rect">
-            <a:avLst/>
-          </a:prstGeom>
-          <a:noFill/>
-        </p:spPr>
-        <p:txBody>
-          <a:bodyPr wrap="square">
-            <a:spAutoFit/>
-          </a:bodyPr>
-          <a:lstStyle/>
-          <a:p>
-            <a:pPr algn="r"/>
-            <a:r>
-              <a:rPr sz="1000" b="1">
-                <a:solidFill>
-                  <a:srgbClr val="555555"/>
-                </a:solidFill>
-                <a:latin typeface="AppleGothic"/>
-                <a:ea typeface="AppleGothic"/>
-              </a:rPr>
-              <a:t>12/12</a:t>
+              <a:t>11/11</a:t>
             </a:r>
           </a:p>
         </p:txBody>
@@ -4744,7 +4436,7 @@
                 <a:latin typeface="AppleGothic"/>
                 <a:ea typeface="AppleGothic"/>
               </a:rPr>
-              <a:t>2/12</a:t>
+              <a:t>2/11</a:t>
             </a:r>
           </a:p>
         </p:txBody>
@@ -5051,7 +4743,7 @@
                 <a:latin typeface="AppleGothic"/>
                 <a:ea typeface="AppleGothic"/>
               </a:rPr>
-              <a:t>3/12</a:t>
+              <a:t>3/11</a:t>
             </a:r>
           </a:p>
         </p:txBody>
@@ -5358,7 +5050,7 @@
                 <a:latin typeface="AppleGothic"/>
                 <a:ea typeface="AppleGothic"/>
               </a:rPr>
-              <a:t>4/12</a:t>
+              <a:t>4/11</a:t>
             </a:r>
           </a:p>
         </p:txBody>
@@ -5665,7 +5357,7 @@
                 <a:latin typeface="AppleGothic"/>
                 <a:ea typeface="AppleGothic"/>
               </a:rPr>
-              <a:t>5/12</a:t>
+              <a:t>5/11</a:t>
             </a:r>
           </a:p>
         </p:txBody>
@@ -5972,7 +5664,7 @@
                 <a:latin typeface="AppleGothic"/>
                 <a:ea typeface="AppleGothic"/>
               </a:rPr>
-              <a:t>6/12</a:t>
+              <a:t>6/11</a:t>
             </a:r>
           </a:p>
         </p:txBody>
@@ -6279,7 +5971,7 @@
                 <a:latin typeface="AppleGothic"/>
                 <a:ea typeface="AppleGothic"/>
               </a:rPr>
-              <a:t>7/12</a:t>
+              <a:t>7/11</a:t>
             </a:r>
           </a:p>
         </p:txBody>
@@ -6455,7 +6147,7 @@
                 <a:latin typeface="AppleGothic"/>
                 <a:ea typeface="AppleGothic"/>
               </a:rPr>
-              <a:t>양의 8곳 × 알고리즘 $R^2$</a:t>
+              <a:t>양의 8곳 × 전 알고리즘 (SAAR … TabPFN 한 그래프)</a:t>
             </a:r>
           </a:p>
         </p:txBody>
@@ -6476,8 +6168,8 @@
         </p:blipFill>
         <p:spPr>
           <a:xfrm>
-            <a:off x="285750" y="762000"/>
-            <a:ext cx="11620500" cy="5334000"/>
+            <a:off x="381000" y="742950"/>
+            <a:ext cx="11430000" cy="5334000"/>
           </a:xfrm>
           <a:prstGeom prst="rect">
             <a:avLst/>
@@ -6586,7 +6278,7 @@
                 <a:latin typeface="AppleGothic"/>
                 <a:ea typeface="AppleGothic"/>
               </a:rPr>
-              <a:t>8/12</a:t>
+              <a:t>8/11</a:t>
             </a:r>
           </a:p>
         </p:txBody>
@@ -6726,7 +6418,7 @@
                 <a:latin typeface="AppleGothic"/>
                 <a:ea typeface="AppleGothic"/>
               </a:rPr>
-              <a:t>SAAR vs TabPFN</a:t>
+              <a:t>안정성</a:t>
             </a:r>
           </a:p>
         </p:txBody>
@@ -6762,14 +6454,14 @@
                 <a:latin typeface="AppleGothic"/>
                 <a:ea typeface="AppleGothic"/>
               </a:rPr>
-              <a:t>표 수치 기반 막대 비교</a:t>
+              <a:t>bootstrap CI  ·  MICH unit $R^2$</a:t>
             </a:r>
           </a:p>
         </p:txBody>
       </p:sp>
       <p:pic>
         <p:nvPicPr>
-          <p:cNvPr id="6" name="Picture 5" descr="pp_vs_tabpfn.png"/>
+          <p:cNvPr id="6" name="Picture 5" descr="robustness_panel.png"/>
           <p:cNvPicPr>
             <a:picLocks noChangeAspect="1"/>
           </p:cNvPicPr>
@@ -6783,8 +6475,8 @@
         </p:blipFill>
         <p:spPr>
           <a:xfrm>
-            <a:off x="381000" y="857250"/>
-            <a:ext cx="11430000" cy="5143500"/>
+            <a:off x="285750" y="857250"/>
+            <a:ext cx="11620500" cy="5048250"/>
           </a:xfrm>
           <a:prstGeom prst="rect">
             <a:avLst/>
@@ -6893,7 +6585,7 @@
                 <a:latin typeface="AppleGothic"/>
                 <a:ea typeface="AppleGothic"/>
               </a:rPr>
-              <a:t>9/12</a:t>
+              <a:t>9/11</a:t>
             </a:r>
           </a:p>
         </p:txBody>

</xml_diff>

<commit_message>
Use native PowerPoint tables for numeric tables.
Keep charts as high-DPI figures; replace rasterized result/failure/limit tables with editable PPT table objects.

Co-authored-by: Cursor <cursoragent@cursor.com>
</commit_message>
<xml_diff>
--- a/output/PP_Research_Detailed_v2.pptx
+++ b/output/PP_Research_Detailed_v2.pptx
@@ -3564,57 +3564,1187 @@
           </a:p>
         </p:txBody>
       </p:sp>
-      <p:pic>
-        <p:nvPicPr>
-          <p:cNvPr id="6" name="Picture 5" descr="fail_cases.png"/>
-          <p:cNvPicPr>
-            <a:picLocks noChangeAspect="1"/>
-          </p:cNvPicPr>
-          <p:nvPr/>
-        </p:nvPicPr>
-        <p:blipFill>
-          <a:blip r:embed="rId2"/>
-          <a:stretch>
-            <a:fillRect/>
-          </a:stretch>
-        </p:blipFill>
-        <p:spPr>
-          <a:xfrm>
-            <a:off x="285750" y="809625"/>
-            <a:ext cx="5905500" cy="4953000"/>
+      <p:sp>
+        <p:nvSpPr>
+          <p:cNvPr id="6" name="TextBox 5"/>
+          <p:cNvSpPr txBox="1"/>
+          <p:nvPr/>
+        </p:nvSpPr>
+        <p:spPr>
+          <a:xfrm>
+            <a:off x="457200" y="857250"/>
+            <a:ext cx="5715000" cy="228600"/>
           </a:xfrm>
           <a:prstGeom prst="rect">
             <a:avLst/>
           </a:prstGeom>
-        </p:spPr>
-      </p:pic>
-      <p:pic>
-        <p:nvPicPr>
-          <p:cNvPr id="7" name="Picture 6" descr="status_compact.png"/>
-          <p:cNvPicPr>
-            <a:picLocks noChangeAspect="1"/>
-          </p:cNvPicPr>
-          <p:nvPr/>
-        </p:nvPicPr>
-        <p:blipFill>
-          <a:blip r:embed="rId3"/>
-          <a:stretch>
-            <a:fillRect/>
-          </a:stretch>
-        </p:blipFill>
-        <p:spPr>
-          <a:xfrm>
-            <a:off x="6286500" y="809625"/>
-            <a:ext cx="5334000" cy="4953000"/>
+          <a:noFill/>
+        </p:spPr>
+        <p:txBody>
+          <a:bodyPr wrap="square">
+            <a:spAutoFit/>
+          </a:bodyPr>
+          <a:lstStyle/>
+          <a:p>
+            <a:pPr algn="l"/>
+            <a:r>
+              <a:rPr sz="1400" b="1">
+                <a:solidFill>
+                  <a:srgbClr val="111111"/>
+                </a:solidFill>
+                <a:latin typeface="AppleGothic"/>
+                <a:ea typeface="AppleGothic"/>
+              </a:rPr>
+              <a:t>실패 설정</a:t>
+            </a:r>
+          </a:p>
+        </p:txBody>
+      </p:sp>
+      <p:graphicFrame>
+        <p:nvGraphicFramePr>
+          <p:cNvPr id="7" name="Table 6"/>
+          <p:cNvGraphicFramePr>
+            <a:graphicFrameLocks noGrp="1"/>
+          </p:cNvGraphicFramePr>
+          <p:nvPr/>
+        </p:nvGraphicFramePr>
+        <p:xfrm>
+          <a:off x="457200" y="1143000"/>
+          <a:ext cx="11277600" cy="2286000"/>
+        </p:xfrm>
+        <a:graphic>
+          <a:graphicData uri="http://schemas.openxmlformats.org/drawingml/2006/table">
+            <a:tbl>
+              <a:tblPr firstRow="1" bandRow="1">
+                <a:tableStyleId>{5C22544A-7EE6-4342-B048-85BDC9FD1C3A}</a:tableStyleId>
+              </a:tblPr>
+              <a:tblGrid>
+                <a:gridCol w="2819400"/>
+                <a:gridCol w="2819400"/>
+                <a:gridCol w="2819400"/>
+                <a:gridCol w="2819400"/>
+              </a:tblGrid>
+              <a:tr h="457200">
+                <a:tc>
+                  <a:txBody>
+                    <a:bodyPr/>
+                    <a:lstStyle/>
+                    <a:p>
+                      <a:pPr algn="ctr"/>
+                      <a:r>
+                        <a:rPr sz="1200" b="1">
+                          <a:solidFill>
+                            <a:srgbClr val="FFFFFF"/>
+                          </a:solidFill>
+                          <a:latin typeface="AppleGothic"/>
+                          <a:ea typeface="AppleGothic"/>
+                        </a:rPr>
+                        <a:t>설정</a:t>
+                      </a:r>
+                    </a:p>
+                  </a:txBody>
+                  <a:tcPr anchor="ctr">
+                    <a:solidFill>
+                      <a:srgbClr val="111111"/>
+                    </a:solidFill>
+                  </a:tcPr>
+                </a:tc>
+                <a:tc>
+                  <a:txBody>
+                    <a:bodyPr/>
+                    <a:lstStyle/>
+                    <a:p>
+                      <a:pPr algn="ctr"/>
+                      <a:r>
+                        <a:rPr sz="1200" b="1">
+                          <a:solidFill>
+                            <a:srgbClr val="FFFFFF"/>
+                          </a:solidFill>
+                          <a:latin typeface="AppleGothic"/>
+                          <a:ea typeface="AppleGothic"/>
+                        </a:rPr>
+                        <a:t>기본 PP R²</a:t>
+                      </a:r>
+                    </a:p>
+                  </a:txBody>
+                  <a:tcPr anchor="ctr">
+                    <a:solidFill>
+                      <a:srgbClr val="111111"/>
+                    </a:solidFill>
+                  </a:tcPr>
+                </a:tc>
+                <a:tc>
+                  <a:txBody>
+                    <a:bodyPr/>
+                    <a:lstStyle/>
+                    <a:p>
+                      <a:pPr algn="ctr"/>
+                      <a:r>
+                        <a:rPr sz="1200" b="1">
+                          <a:solidFill>
+                            <a:srgbClr val="FFFFFF"/>
+                          </a:solidFill>
+                          <a:latin typeface="AppleGothic"/>
+                          <a:ea typeface="AppleGothic"/>
+                        </a:rPr>
+                        <a:t>해석</a:t>
+                      </a:r>
+                    </a:p>
+                  </a:txBody>
+                  <a:tcPr anchor="ctr">
+                    <a:solidFill>
+                      <a:srgbClr val="111111"/>
+                    </a:solidFill>
+                  </a:tcPr>
+                </a:tc>
+                <a:tc>
+                  <a:txBody>
+                    <a:bodyPr/>
+                    <a:lstStyle/>
+                    <a:p>
+                      <a:pPr algn="ctr"/>
+                      <a:r>
+                        <a:rPr sz="1200" b="1">
+                          <a:solidFill>
+                            <a:srgbClr val="FFFFFF"/>
+                          </a:solidFill>
+                          <a:latin typeface="AppleGothic"/>
+                          <a:ea typeface="AppleGothic"/>
+                        </a:rPr>
+                        <a:t>조치</a:t>
+                      </a:r>
+                    </a:p>
+                  </a:txBody>
+                  <a:tcPr anchor="ctr">
+                    <a:solidFill>
+                      <a:srgbClr val="111111"/>
+                    </a:solidFill>
+                  </a:tcPr>
+                </a:tc>
+              </a:tr>
+              <a:tr h="457200">
+                <a:tc>
+                  <a:txBody>
+                    <a:bodyPr/>
+                    <a:lstStyle/>
+                    <a:p>
+                      <a:pPr algn="l"/>
+                      <a:r>
+                        <a:rPr sz="1200" b="1">
+                          <a:solidFill>
+                            <a:srgbClr val="111111"/>
+                          </a:solidFill>
+                          <a:latin typeface="AppleGothic"/>
+                          <a:ea typeface="AppleGothic"/>
+                        </a:rPr>
+                        <a:t>MICH (기본)</a:t>
+                      </a:r>
+                    </a:p>
+                  </a:txBody>
+                  <a:tcPr anchor="ctr">
+                    <a:solidFill>
+                      <a:srgbClr val="FFFFFF"/>
+                    </a:solidFill>
+                  </a:tcPr>
+                </a:tc>
+                <a:tc>
+                  <a:txBody>
+                    <a:bodyPr/>
+                    <a:lstStyle/>
+                    <a:p>
+                      <a:pPr algn="ctr"/>
+                      <a:r>
+                        <a:rPr sz="1200" b="1">
+                          <a:solidFill>
+                            <a:srgbClr val="9B1C1C"/>
+                          </a:solidFill>
+                          <a:latin typeface="AppleGothic"/>
+                          <a:ea typeface="AppleGothic"/>
+                        </a:rPr>
+                        <a:t>-1.522</a:t>
+                      </a:r>
+                    </a:p>
+                  </a:txBody>
+                  <a:tcPr anchor="ctr">
+                    <a:solidFill>
+                      <a:srgbClr val="FFFFFF"/>
+                    </a:solidFill>
+                  </a:tcPr>
+                </a:tc>
+                <a:tc>
+                  <a:txBody>
+                    <a:bodyPr/>
+                    <a:lstStyle/>
+                    <a:p>
+                      <a:pPr algn="l"/>
+                      <a:r>
+                        <a:rPr sz="1200" b="0">
+                          <a:solidFill>
+                            <a:srgbClr val="111111"/>
+                          </a:solidFill>
+                          <a:latin typeface="AppleGothic"/>
+                          <a:ea typeface="AppleGothic"/>
+                        </a:rPr>
+                        <a:t>관계 이동 · 보정 꺼짐</a:t>
+                      </a:r>
+                    </a:p>
+                  </a:txBody>
+                  <a:tcPr anchor="ctr">
+                    <a:solidFill>
+                      <a:srgbClr val="FFFFFF"/>
+                    </a:solidFill>
+                  </a:tcPr>
+                </a:tc>
+                <a:tc>
+                  <a:txBody>
+                    <a:bodyPr/>
+                    <a:lstStyle/>
+                    <a:p>
+                      <a:pPr algn="l"/>
+                      <a:r>
+                        <a:rPr sz="1200" b="0">
+                          <a:solidFill>
+                            <a:srgbClr val="111111"/>
+                          </a:solidFill>
+                          <a:latin typeface="AppleGothic"/>
+                          <a:ea typeface="AppleGothic"/>
+                        </a:rPr>
+                        <a:t>경계 + dual-scale → 0.751</a:t>
+                      </a:r>
+                    </a:p>
+                  </a:txBody>
+                  <a:tcPr anchor="ctr">
+                    <a:solidFill>
+                      <a:srgbClr val="FFFFFF"/>
+                    </a:solidFill>
+                  </a:tcPr>
+                </a:tc>
+              </a:tr>
+              <a:tr h="457200">
+                <a:tc>
+                  <a:txBody>
+                    <a:bodyPr/>
+                    <a:lstStyle/>
+                    <a:p>
+                      <a:pPr algn="l"/>
+                      <a:r>
+                        <a:rPr sz="1200" b="1">
+                          <a:solidFill>
+                            <a:srgbClr val="111111"/>
+                          </a:solidFill>
+                          <a:latin typeface="AppleGothic"/>
+                          <a:ea typeface="AppleGothic"/>
+                        </a:rPr>
+                        <a:t>XJTU</a:t>
+                      </a:r>
+                    </a:p>
+                  </a:txBody>
+                  <a:tcPr anchor="ctr">
+                    <a:solidFill>
+                      <a:srgbClr val="F2F2F0"/>
+                    </a:solidFill>
+                  </a:tcPr>
+                </a:tc>
+                <a:tc>
+                  <a:txBody>
+                    <a:bodyPr/>
+                    <a:lstStyle/>
+                    <a:p>
+                      <a:pPr algn="ctr"/>
+                      <a:r>
+                        <a:rPr sz="1200" b="1">
+                          <a:solidFill>
+                            <a:srgbClr val="9B1C1C"/>
+                          </a:solidFill>
+                          <a:latin typeface="AppleGothic"/>
+                          <a:ea typeface="AppleGothic"/>
+                        </a:rPr>
+                        <a:t>-1.229</a:t>
+                      </a:r>
+                    </a:p>
+                  </a:txBody>
+                  <a:tcPr anchor="ctr">
+                    <a:solidFill>
+                      <a:srgbClr val="F2F2F0"/>
+                    </a:solidFill>
+                  </a:tcPr>
+                </a:tc>
+                <a:tc>
+                  <a:txBody>
+                    <a:bodyPr/>
+                    <a:lstStyle/>
+                    <a:p>
+                      <a:pPr algn="l"/>
+                      <a:r>
+                        <a:rPr sz="1200" b="0">
+                          <a:solidFill>
+                            <a:srgbClr val="111111"/>
+                          </a:solidFill>
+                          <a:latin typeface="AppleGothic"/>
+                          <a:ea typeface="AppleGothic"/>
+                        </a:rPr>
+                        <a:t>val/test 이동 반대</a:t>
+                      </a:r>
+                    </a:p>
+                  </a:txBody>
+                  <a:tcPr anchor="ctr">
+                    <a:solidFill>
+                      <a:srgbClr val="F2F2F0"/>
+                    </a:solidFill>
+                  </a:tcPr>
+                </a:tc>
+                <a:tc>
+                  <a:txBody>
+                    <a:bodyPr/>
+                    <a:lstStyle/>
+                    <a:p>
+                      <a:pPr algn="l"/>
+                      <a:r>
+                        <a:rPr sz="1200" b="0">
+                          <a:solidFill>
+                            <a:srgbClr val="111111"/>
+                          </a:solidFill>
+                          <a:latin typeface="AppleGothic"/>
+                          <a:ea typeface="AppleGothic"/>
+                        </a:rPr>
+                        <a:t>거절 / 옮기지 않음</a:t>
+                      </a:r>
+                    </a:p>
+                  </a:txBody>
+                  <a:tcPr anchor="ctr">
+                    <a:solidFill>
+                      <a:srgbClr val="F2F2F0"/>
+                    </a:solidFill>
+                  </a:tcPr>
+                </a:tc>
+              </a:tr>
+              <a:tr h="457200">
+                <a:tc>
+                  <a:txBody>
+                    <a:bodyPr/>
+                    <a:lstStyle/>
+                    <a:p>
+                      <a:pPr algn="l"/>
+                      <a:r>
+                        <a:rPr sz="1200" b="1">
+                          <a:solidFill>
+                            <a:srgbClr val="111111"/>
+                          </a:solidFill>
+                          <a:latin typeface="AppleGothic"/>
+                          <a:ea typeface="AppleGothic"/>
+                        </a:rPr>
+                        <a:t>FEMTO</a:t>
+                      </a:r>
+                    </a:p>
+                  </a:txBody>
+                  <a:tcPr anchor="ctr">
+                    <a:solidFill>
+                      <a:srgbClr val="FFFFFF"/>
+                    </a:solidFill>
+                  </a:tcPr>
+                </a:tc>
+                <a:tc>
+                  <a:txBody>
+                    <a:bodyPr/>
+                    <a:lstStyle/>
+                    <a:p>
+                      <a:pPr algn="ctr"/>
+                      <a:r>
+                        <a:rPr sz="1200" b="1">
+                          <a:solidFill>
+                            <a:srgbClr val="9B1C1C"/>
+                          </a:solidFill>
+                          <a:latin typeface="AppleGothic"/>
+                          <a:ea typeface="AppleGothic"/>
+                        </a:rPr>
+                        <a:t>-1.378</a:t>
+                      </a:r>
+                    </a:p>
+                  </a:txBody>
+                  <a:tcPr anchor="ctr">
+                    <a:solidFill>
+                      <a:srgbClr val="FFFFFF"/>
+                    </a:solidFill>
+                  </a:tcPr>
+                </a:tc>
+                <a:tc>
+                  <a:txBody>
+                    <a:bodyPr/>
+                    <a:lstStyle/>
+                    <a:p>
+                      <a:pPr algn="l"/>
+                      <a:r>
+                        <a:rPr sz="1200" b="0">
+                          <a:solidFill>
+                            <a:srgbClr val="111111"/>
+                          </a:solidFill>
+                          <a:latin typeface="AppleGothic"/>
+                          <a:ea typeface="AppleGothic"/>
+                        </a:rPr>
+                        <a:t>끝점 희소 · 채널 이슈</a:t>
+                      </a:r>
+                    </a:p>
+                  </a:txBody>
+                  <a:tcPr anchor="ctr">
+                    <a:solidFill>
+                      <a:srgbClr val="FFFFFF"/>
+                    </a:solidFill>
+                  </a:tcPr>
+                </a:tc>
+                <a:tc>
+                  <a:txBody>
+                    <a:bodyPr/>
+                    <a:lstStyle/>
+                    <a:p>
+                      <a:pPr algn="l"/>
+                      <a:r>
+                        <a:rPr sz="1200" b="0">
+                          <a:solidFill>
+                            <a:srgbClr val="111111"/>
+                          </a:solidFill>
+                          <a:latin typeface="AppleGothic"/>
+                          <a:ea typeface="AppleGothic"/>
+                        </a:rPr>
+                        <a:t>설계 미성숙 · 보류</a:t>
+                      </a:r>
+                    </a:p>
+                  </a:txBody>
+                  <a:tcPr anchor="ctr">
+                    <a:solidFill>
+                      <a:srgbClr val="FFFFFF"/>
+                    </a:solidFill>
+                  </a:tcPr>
+                </a:tc>
+              </a:tr>
+              <a:tr h="457200">
+                <a:tc>
+                  <a:txBody>
+                    <a:bodyPr/>
+                    <a:lstStyle/>
+                    <a:p>
+                      <a:pPr algn="l"/>
+                      <a:r>
+                        <a:rPr sz="1200" b="1">
+                          <a:solidFill>
+                            <a:srgbClr val="111111"/>
+                          </a:solidFill>
+                          <a:latin typeface="AppleGothic"/>
+                          <a:ea typeface="AppleGothic"/>
+                        </a:rPr>
+                        <a:t>NASA milling</a:t>
+                      </a:r>
+                    </a:p>
+                  </a:txBody>
+                  <a:tcPr anchor="ctr">
+                    <a:solidFill>
+                      <a:srgbClr val="F2F2F0"/>
+                    </a:solidFill>
+                  </a:tcPr>
+                </a:tc>
+                <a:tc>
+                  <a:txBody>
+                    <a:bodyPr/>
+                    <a:lstStyle/>
+                    <a:p>
+                      <a:pPr algn="ctr"/>
+                      <a:r>
+                        <a:rPr sz="1200" b="1">
+                          <a:solidFill>
+                            <a:srgbClr val="9B1C1C"/>
+                          </a:solidFill>
+                          <a:latin typeface="AppleGothic"/>
+                          <a:ea typeface="AppleGothic"/>
+                        </a:rPr>
+                        <a:t>-4.826</a:t>
+                      </a:r>
+                    </a:p>
+                  </a:txBody>
+                  <a:tcPr anchor="ctr">
+                    <a:solidFill>
+                      <a:srgbClr val="F2F2F0"/>
+                    </a:solidFill>
+                  </a:tcPr>
+                </a:tc>
+                <a:tc>
+                  <a:txBody>
+                    <a:bodyPr/>
+                    <a:lstStyle/>
+                    <a:p>
+                      <a:pPr algn="l"/>
+                      <a:r>
+                        <a:rPr sz="1200" b="0">
+                          <a:solidFill>
+                            <a:srgbClr val="111111"/>
+                          </a:solidFill>
+                          <a:latin typeface="AppleGothic"/>
+                          <a:ea typeface="AppleGothic"/>
+                        </a:rPr>
+                        <a:t>메커니즘 전이 · unit 극소</a:t>
+                      </a:r>
+                    </a:p>
+                  </a:txBody>
+                  <a:tcPr anchor="ctr">
+                    <a:solidFill>
+                      <a:srgbClr val="F2F2F0"/>
+                    </a:solidFill>
+                  </a:tcPr>
+                </a:tc>
+                <a:tc>
+                  <a:txBody>
+                    <a:bodyPr/>
+                    <a:lstStyle/>
+                    <a:p>
+                      <a:pPr algn="l"/>
+                      <a:r>
+                        <a:rPr sz="1200" b="0">
+                          <a:solidFill>
+                            <a:srgbClr val="111111"/>
+                          </a:solidFill>
+                          <a:latin typeface="AppleGothic"/>
+                          <a:ea typeface="AppleGothic"/>
+                        </a:rPr>
+                        <a:t>사전 Fail / ABSTAIN</a:t>
+                      </a:r>
+                    </a:p>
+                  </a:txBody>
+                  <a:tcPr anchor="ctr">
+                    <a:solidFill>
+                      <a:srgbClr val="F2F2F0"/>
+                    </a:solidFill>
+                  </a:tcPr>
+                </a:tc>
+              </a:tr>
+            </a:tbl>
+          </a:graphicData>
+        </a:graphic>
+      </p:graphicFrame>
+      <p:sp>
+        <p:nvSpPr>
+          <p:cNvPr id="8" name="TextBox 7"/>
+          <p:cNvSpPr txBox="1"/>
+          <p:nvPr/>
+        </p:nvSpPr>
+        <p:spPr>
+          <a:xfrm>
+            <a:off x="457200" y="3714750"/>
+            <a:ext cx="5334000" cy="228600"/>
           </a:xfrm>
           <a:prstGeom prst="rect">
             <a:avLst/>
           </a:prstGeom>
-        </p:spPr>
-      </p:pic>
+          <a:noFill/>
+        </p:spPr>
+        <p:txBody>
+          <a:bodyPr wrap="square">
+            <a:spAutoFit/>
+          </a:bodyPr>
+          <a:lstStyle/>
+          <a:p>
+            <a:pPr algn="l"/>
+            <a:r>
+              <a:rPr sz="1300" b="1">
+                <a:solidFill>
+                  <a:srgbClr val="0A5C5C"/>
+                </a:solidFill>
+                <a:latin typeface="AppleGothic"/>
+                <a:ea typeface="AppleGothic"/>
+              </a:rPr>
+              <a:t>주장하는 것</a:t>
+            </a:r>
+          </a:p>
+        </p:txBody>
+      </p:sp>
+      <p:graphicFrame>
+        <p:nvGraphicFramePr>
+          <p:cNvPr id="9" name="Table 8"/>
+          <p:cNvGraphicFramePr>
+            <a:graphicFrameLocks noGrp="1"/>
+          </p:cNvGraphicFramePr>
+          <p:nvPr/>
+        </p:nvGraphicFramePr>
+        <p:xfrm>
+          <a:off x="457200" y="4000500"/>
+          <a:ext cx="5334000" cy="1905000"/>
+        </p:xfrm>
+        <a:graphic>
+          <a:graphicData uri="http://schemas.openxmlformats.org/drawingml/2006/table">
+            <a:tbl>
+              <a:tblPr firstRow="1" bandRow="1">
+                <a:tableStyleId>{5C22544A-7EE6-4342-B048-85BDC9FD1C3A}</a:tableStyleId>
+              </a:tblPr>
+              <a:tblGrid>
+                <a:gridCol w="2667000"/>
+                <a:gridCol w="2667000"/>
+              </a:tblGrid>
+              <a:tr h="381000">
+                <a:tc>
+                  <a:txBody>
+                    <a:bodyPr/>
+                    <a:lstStyle/>
+                    <a:p>
+                      <a:pPr algn="ctr"/>
+                      <a:r>
+                        <a:rPr sz="1100" b="1">
+                          <a:solidFill>
+                            <a:srgbClr val="FFFFFF"/>
+                          </a:solidFill>
+                          <a:latin typeface="AppleGothic"/>
+                          <a:ea typeface="AppleGothic"/>
+                        </a:rPr>
+                        <a:t>항목</a:t>
+                      </a:r>
+                    </a:p>
+                  </a:txBody>
+                  <a:tcPr anchor="ctr">
+                    <a:solidFill>
+                      <a:srgbClr val="111111"/>
+                    </a:solidFill>
+                  </a:tcPr>
+                </a:tc>
+                <a:tc>
+                  <a:txBody>
+                    <a:bodyPr/>
+                    <a:lstStyle/>
+                    <a:p>
+                      <a:pPr algn="ctr"/>
+                      <a:r>
+                        <a:rPr sz="1100" b="1">
+                          <a:solidFill>
+                            <a:srgbClr val="FFFFFF"/>
+                          </a:solidFill>
+                          <a:latin typeface="AppleGothic"/>
+                          <a:ea typeface="AppleGothic"/>
+                        </a:rPr>
+                        <a:t>내용</a:t>
+                      </a:r>
+                    </a:p>
+                  </a:txBody>
+                  <a:tcPr anchor="ctr">
+                    <a:solidFill>
+                      <a:srgbClr val="111111"/>
+                    </a:solidFill>
+                  </a:tcPr>
+                </a:tc>
+              </a:tr>
+              <a:tr h="381000">
+                <a:tc>
+                  <a:txBody>
+                    <a:bodyPr/>
+                    <a:lstStyle/>
+                    <a:p>
+                      <a:pPr algn="ctr"/>
+                      <a:r>
+                        <a:rPr sz="1100" b="1">
+                          <a:solidFill>
+                            <a:srgbClr val="111111"/>
+                          </a:solidFill>
+                          <a:latin typeface="AppleGothic"/>
+                          <a:ea typeface="AppleGothic"/>
+                        </a:rPr>
+                        <a:t>주표</a:t>
+                      </a:r>
+                    </a:p>
+                  </a:txBody>
+                  <a:tcPr anchor="ctr">
+                    <a:solidFill>
+                      <a:srgbClr val="FFFFFF"/>
+                    </a:solidFill>
+                  </a:tcPr>
+                </a:tc>
+                <a:tc>
+                  <a:txBody>
+                    <a:bodyPr/>
+                    <a:lstStyle/>
+                    <a:p>
+                      <a:pPr algn="ctr"/>
+                      <a:r>
+                        <a:rPr sz="1100" b="0">
+                          <a:solidFill>
+                            <a:srgbClr val="111111"/>
+                          </a:solidFill>
+                          <a:latin typeface="AppleGothic"/>
+                          <a:ea typeface="AppleGothic"/>
+                        </a:rPr>
+                        <a:t>0.934 / 0.842 / 0.751</a:t>
+                      </a:r>
+                    </a:p>
+                  </a:txBody>
+                  <a:tcPr anchor="ctr">
+                    <a:solidFill>
+                      <a:srgbClr val="FFFFFF"/>
+                    </a:solidFill>
+                  </a:tcPr>
+                </a:tc>
+              </a:tr>
+              <a:tr h="381000">
+                <a:tc>
+                  <a:txBody>
+                    <a:bodyPr/>
+                    <a:lstStyle/>
+                    <a:p>
+                      <a:pPr algn="ctr"/>
+                      <a:r>
+                        <a:rPr sz="1100" b="1">
+                          <a:solidFill>
+                            <a:srgbClr val="111111"/>
+                          </a:solidFill>
+                          <a:latin typeface="AppleGothic"/>
+                          <a:ea typeface="AppleGothic"/>
+                        </a:rPr>
+                        <a:t>범위</a:t>
+                      </a:r>
+                    </a:p>
+                  </a:txBody>
+                  <a:tcPr anchor="ctr">
+                    <a:solidFill>
+                      <a:srgbClr val="F2F2F0"/>
+                    </a:solidFill>
+                  </a:tcPr>
+                </a:tc>
+                <a:tc>
+                  <a:txBody>
+                    <a:bodyPr/>
+                    <a:lstStyle/>
+                    <a:p>
+                      <a:pPr algn="ctr"/>
+                      <a:r>
+                        <a:rPr sz="1100" b="0">
+                          <a:solidFill>
+                            <a:srgbClr val="111111"/>
+                          </a:solidFill>
+                          <a:latin typeface="AppleGothic"/>
+                          <a:ea typeface="AppleGothic"/>
+                        </a:rPr>
+                        <a:t>연속 열화 · unit-disjoint · hull-out</a:t>
+                      </a:r>
+                    </a:p>
+                  </a:txBody>
+                  <a:tcPr anchor="ctr">
+                    <a:solidFill>
+                      <a:srgbClr val="F2F2F0"/>
+                    </a:solidFill>
+                  </a:tcPr>
+                </a:tc>
+              </a:tr>
+              <a:tr h="381000">
+                <a:tc>
+                  <a:txBody>
+                    <a:bodyPr/>
+                    <a:lstStyle/>
+                    <a:p>
+                      <a:pPr algn="ctr"/>
+                      <a:r>
+                        <a:rPr sz="1100" b="1">
+                          <a:solidFill>
+                            <a:srgbClr val="111111"/>
+                          </a:solidFill>
+                          <a:latin typeface="AppleGothic"/>
+                          <a:ea typeface="AppleGothic"/>
+                        </a:rPr>
+                        <a:t>방법</a:t>
+                      </a:r>
+                    </a:p>
+                  </a:txBody>
+                  <a:tcPr anchor="ctr">
+                    <a:solidFill>
+                      <a:srgbClr val="FFFFFF"/>
+                    </a:solidFill>
+                  </a:tcPr>
+                </a:tc>
+                <a:tc>
+                  <a:txBody>
+                    <a:bodyPr/>
+                    <a:lstStyle/>
+                    <a:p>
+                      <a:pPr algn="ctr"/>
+                      <a:r>
+                        <a:rPr sz="1100" b="0">
+                          <a:solidFill>
+                            <a:srgbClr val="111111"/>
+                          </a:solidFill>
+                          <a:latin typeface="AppleGothic"/>
+                          <a:ea typeface="AppleGothic"/>
+                        </a:rPr>
+                        <a:t>동결 affine + dual-scale residual</a:t>
+                      </a:r>
+                    </a:p>
+                  </a:txBody>
+                  <a:tcPr anchor="ctr">
+                    <a:solidFill>
+                      <a:srgbClr val="FFFFFF"/>
+                    </a:solidFill>
+                  </a:tcPr>
+                </a:tc>
+              </a:tr>
+              <a:tr h="381000">
+                <a:tc>
+                  <a:txBody>
+                    <a:bodyPr/>
+                    <a:lstStyle/>
+                    <a:p>
+                      <a:pPr algn="ctr"/>
+                      <a:r>
+                        <a:rPr sz="1100" b="1">
+                          <a:solidFill>
+                            <a:srgbClr val="111111"/>
+                          </a:solidFill>
+                          <a:latin typeface="AppleGothic"/>
+                          <a:ea typeface="AppleGothic"/>
+                        </a:rPr>
+                        <a:t>타깃</a:t>
+                      </a:r>
+                    </a:p>
+                  </a:txBody>
+                  <a:tcPr anchor="ctr">
+                    <a:solidFill>
+                      <a:srgbClr val="F2F2F0"/>
+                    </a:solidFill>
+                  </a:tcPr>
+                </a:tc>
+                <a:tc>
+                  <a:txBody>
+                    <a:bodyPr/>
+                    <a:lstStyle/>
+                    <a:p>
+                      <a:pPr algn="ctr"/>
+                      <a:r>
+                        <a:rPr sz="1100" b="0">
+                          <a:solidFill>
+                            <a:srgbClr val="111111"/>
+                          </a:solidFill>
+                          <a:latin typeface="AppleGothic"/>
+                          <a:ea typeface="AppleGothic"/>
+                        </a:rPr>
+                        <a:t>분야 Q1–Q2</a:t>
+                      </a:r>
+                    </a:p>
+                  </a:txBody>
+                  <a:tcPr anchor="ctr">
+                    <a:solidFill>
+                      <a:srgbClr val="F2F2F0"/>
+                    </a:solidFill>
+                  </a:tcPr>
+                </a:tc>
+              </a:tr>
+            </a:tbl>
+          </a:graphicData>
+        </a:graphic>
+      </p:graphicFrame>
+      <p:sp>
+        <p:nvSpPr>
+          <p:cNvPr id="10" name="TextBox 9"/>
+          <p:cNvSpPr txBox="1"/>
+          <p:nvPr/>
+        </p:nvSpPr>
+        <p:spPr>
+          <a:xfrm>
+            <a:off x="6096000" y="3714750"/>
+            <a:ext cx="5334000" cy="228600"/>
+          </a:xfrm>
+          <a:prstGeom prst="rect">
+            <a:avLst/>
+          </a:prstGeom>
+          <a:noFill/>
+        </p:spPr>
+        <p:txBody>
+          <a:bodyPr wrap="square">
+            <a:spAutoFit/>
+          </a:bodyPr>
+          <a:lstStyle/>
+          <a:p>
+            <a:pPr algn="l"/>
+            <a:r>
+              <a:rPr sz="1300" b="1">
+                <a:solidFill>
+                  <a:srgbClr val="9B1C1C"/>
+                </a:solidFill>
+                <a:latin typeface="AppleGothic"/>
+                <a:ea typeface="AppleGothic"/>
+              </a:rPr>
+              <a:t>아직 주장하지 않는 것</a:t>
+            </a:r>
+          </a:p>
+        </p:txBody>
+      </p:sp>
+      <p:graphicFrame>
+        <p:nvGraphicFramePr>
+          <p:cNvPr id="11" name="Table 10"/>
+          <p:cNvGraphicFramePr>
+            <a:graphicFrameLocks noGrp="1"/>
+          </p:cNvGraphicFramePr>
+          <p:nvPr/>
+        </p:nvGraphicFramePr>
+        <p:xfrm>
+          <a:off x="6096000" y="4000500"/>
+          <a:ext cx="5638800" cy="1905000"/>
+        </p:xfrm>
+        <a:graphic>
+          <a:graphicData uri="http://schemas.openxmlformats.org/drawingml/2006/table">
+            <a:tbl>
+              <a:tblPr firstRow="1" bandRow="1">
+                <a:tableStyleId>{5C22544A-7EE6-4342-B048-85BDC9FD1C3A}</a:tableStyleId>
+              </a:tblPr>
+              <a:tblGrid>
+                <a:gridCol w="2819400"/>
+                <a:gridCol w="2819400"/>
+              </a:tblGrid>
+              <a:tr h="381000">
+                <a:tc>
+                  <a:txBody>
+                    <a:bodyPr/>
+                    <a:lstStyle/>
+                    <a:p>
+                      <a:pPr algn="ctr"/>
+                      <a:r>
+                        <a:rPr sz="1100" b="1">
+                          <a:solidFill>
+                            <a:srgbClr val="FFFFFF"/>
+                          </a:solidFill>
+                          <a:latin typeface="AppleGothic"/>
+                          <a:ea typeface="AppleGothic"/>
+                        </a:rPr>
+                        <a:t>항목</a:t>
+                      </a:r>
+                    </a:p>
+                  </a:txBody>
+                  <a:tcPr anchor="ctr">
+                    <a:solidFill>
+                      <a:srgbClr val="111111"/>
+                    </a:solidFill>
+                  </a:tcPr>
+                </a:tc>
+                <a:tc>
+                  <a:txBody>
+                    <a:bodyPr/>
+                    <a:lstStyle/>
+                    <a:p>
+                      <a:pPr algn="ctr"/>
+                      <a:r>
+                        <a:rPr sz="1100" b="1">
+                          <a:solidFill>
+                            <a:srgbClr val="FFFFFF"/>
+                          </a:solidFill>
+                          <a:latin typeface="AppleGothic"/>
+                          <a:ea typeface="AppleGothic"/>
+                        </a:rPr>
+                        <a:t>내용</a:t>
+                      </a:r>
+                    </a:p>
+                  </a:txBody>
+                  <a:tcPr anchor="ctr">
+                    <a:solidFill>
+                      <a:srgbClr val="111111"/>
+                    </a:solidFill>
+                  </a:tcPr>
+                </a:tc>
+              </a:tr>
+              <a:tr h="381000">
+                <a:tc>
+                  <a:txBody>
+                    <a:bodyPr/>
+                    <a:lstStyle/>
+                    <a:p>
+                      <a:pPr algn="ctr"/>
+                      <a:r>
+                        <a:rPr sz="1100" b="1">
+                          <a:solidFill>
+                            <a:srgbClr val="111111"/>
+                          </a:solidFill>
+                          <a:latin typeface="AppleGothic"/>
+                          <a:ea typeface="AppleGothic"/>
+                        </a:rPr>
+                        <a:t>Zn / Na</a:t>
+                      </a:r>
+                    </a:p>
+                  </a:txBody>
+                  <a:tcPr anchor="ctr">
+                    <a:solidFill>
+                      <a:srgbClr val="FFFFFF"/>
+                    </a:solidFill>
+                  </a:tcPr>
+                </a:tc>
+                <a:tc>
+                  <a:txBody>
+                    <a:bodyPr/>
+                    <a:lstStyle/>
+                    <a:p>
+                      <a:pPr algn="ctr"/>
+                      <a:r>
+                        <a:rPr sz="1100" b="0">
+                          <a:solidFill>
+                            <a:srgbClr val="111111"/>
+                          </a:solidFill>
+                          <a:latin typeface="AppleGothic"/>
+                          <a:ea typeface="AppleGothic"/>
+                        </a:rPr>
+                        <a:t>사후 개발 — untouched 확증 아님</a:t>
+                      </a:r>
+                    </a:p>
+                  </a:txBody>
+                  <a:tcPr anchor="ctr">
+                    <a:solidFill>
+                      <a:srgbClr val="FFFFFF"/>
+                    </a:solidFill>
+                  </a:tcPr>
+                </a:tc>
+              </a:tr>
+              <a:tr h="381000">
+                <a:tc>
+                  <a:txBody>
+                    <a:bodyPr/>
+                    <a:lstStyle/>
+                    <a:p>
+                      <a:pPr algn="ctr"/>
+                      <a:r>
+                        <a:rPr sz="1100" b="1">
+                          <a:solidFill>
+                            <a:srgbClr val="111111"/>
+                          </a:solidFill>
+                          <a:latin typeface="AppleGothic"/>
+                          <a:ea typeface="AppleGothic"/>
+                        </a:rPr>
+                        <a:t>교차도메인</a:t>
+                      </a:r>
+                    </a:p>
+                  </a:txBody>
+                  <a:tcPr anchor="ctr">
+                    <a:solidFill>
+                      <a:srgbClr val="F2F2F0"/>
+                    </a:solidFill>
+                  </a:tcPr>
+                </a:tc>
+                <a:tc>
+                  <a:txBody>
+                    <a:bodyPr/>
+                    <a:lstStyle/>
+                    <a:p>
+                      <a:pPr algn="ctr"/>
+                      <a:r>
+                        <a:rPr sz="1100" b="0">
+                          <a:solidFill>
+                            <a:srgbClr val="111111"/>
+                          </a:solidFill>
+                          <a:latin typeface="AppleGothic"/>
+                          <a:ea typeface="AppleGothic"/>
+                        </a:rPr>
+                        <a:t>XJTU · FEMTO 우월성 전</a:t>
+                      </a:r>
+                    </a:p>
+                  </a:txBody>
+                  <a:tcPr anchor="ctr">
+                    <a:solidFill>
+                      <a:srgbClr val="F2F2F0"/>
+                    </a:solidFill>
+                  </a:tcPr>
+                </a:tc>
+              </a:tr>
+              <a:tr h="381000">
+                <a:tc>
+                  <a:txBody>
+                    <a:bodyPr/>
+                    <a:lstStyle/>
+                    <a:p>
+                      <a:pPr algn="ctr"/>
+                      <a:r>
+                        <a:rPr sz="1100" b="1">
+                          <a:solidFill>
+                            <a:srgbClr val="111111"/>
+                          </a:solidFill>
+                          <a:latin typeface="AppleGothic"/>
+                          <a:ea typeface="AppleGothic"/>
+                        </a:rPr>
+                        <a:t>PAE</a:t>
+                      </a:r>
+                    </a:p>
+                  </a:txBody>
+                  <a:tcPr anchor="ctr">
+                    <a:solidFill>
+                      <a:srgbClr val="FFFFFF"/>
+                    </a:solidFill>
+                  </a:tcPr>
+                </a:tc>
+                <a:tc>
+                  <a:txBody>
+                    <a:bodyPr/>
+                    <a:lstStyle/>
+                    <a:p>
+                      <a:pPr algn="ctr"/>
+                      <a:r>
+                        <a:rPr sz="1100" b="0">
+                          <a:solidFill>
+                            <a:srgbClr val="111111"/>
+                          </a:solidFill>
+                          <a:latin typeface="AppleGothic"/>
+                          <a:ea typeface="AppleGothic"/>
+                        </a:rPr>
+                        <a:t>식 라우팅 실험 없음 · 표 분리</a:t>
+                      </a:r>
+                    </a:p>
+                  </a:txBody>
+                  <a:tcPr anchor="ctr">
+                    <a:solidFill>
+                      <a:srgbClr val="FFFFFF"/>
+                    </a:solidFill>
+                  </a:tcPr>
+                </a:tc>
+              </a:tr>
+              <a:tr h="381000">
+                <a:tc>
+                  <a:txBody>
+                    <a:bodyPr/>
+                    <a:lstStyle/>
+                    <a:p>
+                      <a:pPr algn="ctr"/>
+                      <a:r>
+                        <a:rPr sz="1100" b="1">
+                          <a:solidFill>
+                            <a:srgbClr val="111111"/>
+                          </a:solidFill>
+                          <a:latin typeface="AppleGothic"/>
+                          <a:ea typeface="AppleGothic"/>
+                        </a:rPr>
+                        <a:t>만능 SOTA</a:t>
+                      </a:r>
+                    </a:p>
+                  </a:txBody>
+                  <a:tcPr anchor="ctr">
+                    <a:solidFill>
+                      <a:srgbClr val="F2F2F0"/>
+                    </a:solidFill>
+                  </a:tcPr>
+                </a:tc>
+                <a:tc>
+                  <a:txBody>
+                    <a:bodyPr/>
+                    <a:lstStyle/>
+                    <a:p>
+                      <a:pPr algn="ctr"/>
+                      <a:r>
+                        <a:rPr sz="1100" b="0">
+                          <a:solidFill>
+                            <a:srgbClr val="111111"/>
+                          </a:solidFill>
+                          <a:latin typeface="AppleGothic"/>
+                          <a:ea typeface="AppleGothic"/>
+                        </a:rPr>
+                        <a:t>모든 OOD 1등 아님</a:t>
+                      </a:r>
+                    </a:p>
+                  </a:txBody>
+                  <a:tcPr anchor="ctr">
+                    <a:solidFill>
+                      <a:srgbClr val="F2F2F0"/>
+                    </a:solidFill>
+                  </a:tcPr>
+                </a:tc>
+              </a:tr>
+            </a:tbl>
+          </a:graphicData>
+        </a:graphic>
+      </p:graphicFrame>
       <p:cxnSp>
         <p:nvCxnSpPr>
-          <p:cNvPr id="8" name="Connector 7"/>
+          <p:cNvPr id="12" name="Connector 11"/>
           <p:cNvCxnSpPr/>
           <p:nvPr/>
         </p:nvCxnSpPr>
@@ -3649,7 +4779,7 @@
       </p:cxnSp>
       <p:sp>
         <p:nvSpPr>
-          <p:cNvPr id="9" name="TextBox 8"/>
+          <p:cNvPr id="13" name="TextBox 12"/>
           <p:cNvSpPr txBox="1"/>
           <p:nvPr/>
         </p:nvSpPr>
@@ -3685,7 +4815,7 @@
       </p:sp>
       <p:sp>
         <p:nvSpPr>
-          <p:cNvPr id="10" name="TextBox 9"/>
+          <p:cNvPr id="14" name="TextBox 13"/>
           <p:cNvSpPr txBox="1"/>
           <p:nvPr/>
         </p:nvSpPr>
@@ -5247,17 +6377,329 @@
         </p:blipFill>
         <p:spPr>
           <a:xfrm>
-            <a:off x="381000" y="952500"/>
-            <a:ext cx="11430000" cy="4762500"/>
+            <a:off x="381000" y="904875"/>
+            <a:ext cx="6667500" cy="4000500"/>
           </a:xfrm>
           <a:prstGeom prst="rect">
             <a:avLst/>
           </a:prstGeom>
         </p:spPr>
       </p:pic>
+      <p:graphicFrame>
+        <p:nvGraphicFramePr>
+          <p:cNvPr id="7" name="Table 6"/>
+          <p:cNvGraphicFramePr>
+            <a:graphicFrameLocks noGrp="1"/>
+          </p:cNvGraphicFramePr>
+          <p:nvPr/>
+        </p:nvGraphicFramePr>
+        <p:xfrm>
+          <a:off x="7239000" y="1524000"/>
+          <a:ext cx="4381500" cy="2667000"/>
+        </p:xfrm>
+        <a:graphic>
+          <a:graphicData uri="http://schemas.openxmlformats.org/drawingml/2006/table">
+            <a:tbl>
+              <a:tblPr firstRow="1" bandRow="1">
+                <a:tableStyleId>{5C22544A-7EE6-4342-B048-85BDC9FD1C3A}</a:tableStyleId>
+              </a:tblPr>
+              <a:tblGrid>
+                <a:gridCol w="2190750"/>
+                <a:gridCol w="2190750"/>
+              </a:tblGrid>
+              <a:tr h="533400">
+                <a:tc>
+                  <a:txBody>
+                    <a:bodyPr/>
+                    <a:lstStyle/>
+                    <a:p>
+                      <a:pPr algn="ctr"/>
+                      <a:r>
+                        <a:rPr sz="1400" b="1">
+                          <a:solidFill>
+                            <a:srgbClr val="FFFFFF"/>
+                          </a:solidFill>
+                          <a:latin typeface="AppleGothic"/>
+                          <a:ea typeface="AppleGothic"/>
+                        </a:rPr>
+                        <a:t>데이터</a:t>
+                      </a:r>
+                    </a:p>
+                  </a:txBody>
+                  <a:tcPr anchor="ctr">
+                    <a:solidFill>
+                      <a:srgbClr val="111111"/>
+                    </a:solidFill>
+                  </a:tcPr>
+                </a:tc>
+                <a:tc>
+                  <a:txBody>
+                    <a:bodyPr/>
+                    <a:lstStyle/>
+                    <a:p>
+                      <a:pPr algn="ctr"/>
+                      <a:r>
+                        <a:rPr sz="1400" b="1">
+                          <a:solidFill>
+                            <a:srgbClr val="FFFFFF"/>
+                          </a:solidFill>
+                          <a:latin typeface="AppleGothic"/>
+                          <a:ea typeface="AppleGothic"/>
+                        </a:rPr>
+                        <a:t>R²</a:t>
+                      </a:r>
+                    </a:p>
+                  </a:txBody>
+                  <a:tcPr anchor="ctr">
+                    <a:solidFill>
+                      <a:srgbClr val="111111"/>
+                    </a:solidFill>
+                  </a:tcPr>
+                </a:tc>
+              </a:tr>
+              <a:tr h="533400">
+                <a:tc>
+                  <a:txBody>
+                    <a:bodyPr/>
+                    <a:lstStyle/>
+                    <a:p>
+                      <a:pPr algn="ctr"/>
+                      <a:r>
+                        <a:rPr sz="1400" b="1">
+                          <a:solidFill>
+                            <a:srgbClr val="111111"/>
+                          </a:solidFill>
+                          <a:latin typeface="AppleGothic"/>
+                          <a:ea typeface="AppleGothic"/>
+                        </a:rPr>
+                        <a:t>Sunwoda</a:t>
+                      </a:r>
+                    </a:p>
+                  </a:txBody>
+                  <a:tcPr anchor="ctr">
+                    <a:solidFill>
+                      <a:srgbClr val="FFFFFF"/>
+                    </a:solidFill>
+                  </a:tcPr>
+                </a:tc>
+                <a:tc>
+                  <a:txBody>
+                    <a:bodyPr/>
+                    <a:lstStyle/>
+                    <a:p>
+                      <a:pPr algn="ctr"/>
+                      <a:r>
+                        <a:rPr sz="1400" b="0">
+                          <a:solidFill>
+                            <a:srgbClr val="111111"/>
+                          </a:solidFill>
+                          <a:latin typeface="AppleGothic"/>
+                          <a:ea typeface="AppleGothic"/>
+                        </a:rPr>
+                        <a:t>0.934</a:t>
+                      </a:r>
+                    </a:p>
+                  </a:txBody>
+                  <a:tcPr anchor="ctr">
+                    <a:solidFill>
+                      <a:srgbClr val="FFFFFF"/>
+                    </a:solidFill>
+                  </a:tcPr>
+                </a:tc>
+              </a:tr>
+              <a:tr h="533400">
+                <a:tc>
+                  <a:txBody>
+                    <a:bodyPr/>
+                    <a:lstStyle/>
+                    <a:p>
+                      <a:pPr algn="ctr"/>
+                      <a:r>
+                        <a:rPr sz="1400" b="1">
+                          <a:solidFill>
+                            <a:srgbClr val="111111"/>
+                          </a:solidFill>
+                          <a:latin typeface="AppleGothic"/>
+                          <a:ea typeface="AppleGothic"/>
+                        </a:rPr>
+                        <a:t>RWTH</a:t>
+                      </a:r>
+                    </a:p>
+                  </a:txBody>
+                  <a:tcPr anchor="ctr">
+                    <a:solidFill>
+                      <a:srgbClr val="F2F2F0"/>
+                    </a:solidFill>
+                  </a:tcPr>
+                </a:tc>
+                <a:tc>
+                  <a:txBody>
+                    <a:bodyPr/>
+                    <a:lstStyle/>
+                    <a:p>
+                      <a:pPr algn="ctr"/>
+                      <a:r>
+                        <a:rPr sz="1400" b="0">
+                          <a:solidFill>
+                            <a:srgbClr val="111111"/>
+                          </a:solidFill>
+                          <a:latin typeface="AppleGothic"/>
+                          <a:ea typeface="AppleGothic"/>
+                        </a:rPr>
+                        <a:t>0.842</a:t>
+                      </a:r>
+                    </a:p>
+                  </a:txBody>
+                  <a:tcPr anchor="ctr">
+                    <a:solidFill>
+                      <a:srgbClr val="F2F2F0"/>
+                    </a:solidFill>
+                  </a:tcPr>
+                </a:tc>
+              </a:tr>
+              <a:tr h="533400">
+                <a:tc>
+                  <a:txBody>
+                    <a:bodyPr/>
+                    <a:lstStyle/>
+                    <a:p>
+                      <a:pPr algn="ctr"/>
+                      <a:r>
+                        <a:rPr sz="1400" b="1">
+                          <a:solidFill>
+                            <a:srgbClr val="111111"/>
+                          </a:solidFill>
+                          <a:latin typeface="AppleGothic"/>
+                          <a:ea typeface="AppleGothic"/>
+                        </a:rPr>
+                        <a:t>MICH</a:t>
+                      </a:r>
+                    </a:p>
+                  </a:txBody>
+                  <a:tcPr anchor="ctr">
+                    <a:solidFill>
+                      <a:srgbClr val="FFFFFF"/>
+                    </a:solidFill>
+                  </a:tcPr>
+                </a:tc>
+                <a:tc>
+                  <a:txBody>
+                    <a:bodyPr/>
+                    <a:lstStyle/>
+                    <a:p>
+                      <a:pPr algn="ctr"/>
+                      <a:r>
+                        <a:rPr sz="1400" b="0">
+                          <a:solidFill>
+                            <a:srgbClr val="111111"/>
+                          </a:solidFill>
+                          <a:latin typeface="AppleGothic"/>
+                          <a:ea typeface="AppleGothic"/>
+                        </a:rPr>
+                        <a:t>0.751</a:t>
+                      </a:r>
+                    </a:p>
+                  </a:txBody>
+                  <a:tcPr anchor="ctr">
+                    <a:solidFill>
+                      <a:srgbClr val="FFFFFF"/>
+                    </a:solidFill>
+                  </a:tcPr>
+                </a:tc>
+              </a:tr>
+              <a:tr h="533400">
+                <a:tc>
+                  <a:txBody>
+                    <a:bodyPr/>
+                    <a:lstStyle/>
+                    <a:p>
+                      <a:pPr algn="ctr"/>
+                      <a:r>
+                        <a:rPr sz="1400" b="1">
+                          <a:solidFill>
+                            <a:srgbClr val="0A5C5C"/>
+                          </a:solidFill>
+                          <a:latin typeface="AppleGothic"/>
+                          <a:ea typeface="AppleGothic"/>
+                        </a:rPr>
+                        <a:t>평균</a:t>
+                      </a:r>
+                    </a:p>
+                  </a:txBody>
+                  <a:tcPr anchor="ctr">
+                    <a:solidFill>
+                      <a:srgbClr val="DCEBEB"/>
+                    </a:solidFill>
+                  </a:tcPr>
+                </a:tc>
+                <a:tc>
+                  <a:txBody>
+                    <a:bodyPr/>
+                    <a:lstStyle/>
+                    <a:p>
+                      <a:pPr algn="ctr"/>
+                      <a:r>
+                        <a:rPr sz="1400" b="1">
+                          <a:solidFill>
+                            <a:srgbClr val="0A5C5C"/>
+                          </a:solidFill>
+                          <a:latin typeface="AppleGothic"/>
+                          <a:ea typeface="AppleGothic"/>
+                        </a:rPr>
+                        <a:t>0.842</a:t>
+                      </a:r>
+                    </a:p>
+                  </a:txBody>
+                  <a:tcPr anchor="ctr">
+                    <a:solidFill>
+                      <a:srgbClr val="DCEBEB"/>
+                    </a:solidFill>
+                  </a:tcPr>
+                </a:tc>
+              </a:tr>
+            </a:tbl>
+          </a:graphicData>
+        </a:graphic>
+      </p:graphicFrame>
+      <p:sp>
+        <p:nvSpPr>
+          <p:cNvPr id="8" name="TextBox 7"/>
+          <p:cNvSpPr txBox="1"/>
+          <p:nvPr/>
+        </p:nvSpPr>
+        <p:spPr>
+          <a:xfrm>
+            <a:off x="7239000" y="4381500"/>
+            <a:ext cx="4381500" cy="571500"/>
+          </a:xfrm>
+          <a:prstGeom prst="rect">
+            <a:avLst/>
+          </a:prstGeom>
+          <a:noFill/>
+        </p:spPr>
+        <p:txBody>
+          <a:bodyPr wrap="square">
+            <a:spAutoFit/>
+          </a:bodyPr>
+          <a:lstStyle/>
+          <a:p>
+            <a:pPr algn="l"/>
+            <a:r>
+              <a:rPr sz="1200" b="0">
+                <a:solidFill>
+                  <a:srgbClr val="555555"/>
+                </a:solidFill>
+                <a:latin typeface="AppleGothic"/>
+                <a:ea typeface="AppleGothic"/>
+              </a:rPr>
+              <a:t>만능 SOTA 아님  ·  PAE 결과는 이번 표에 없음</a:t>
+            </a:r>
+          </a:p>
+        </p:txBody>
+      </p:sp>
       <p:cxnSp>
         <p:nvCxnSpPr>
-          <p:cNvPr id="7" name="Connector 6"/>
+          <p:cNvPr id="9" name="Connector 8"/>
           <p:cNvCxnSpPr/>
           <p:nvPr/>
         </p:nvCxnSpPr>
@@ -5292,7 +6734,7 @@
       </p:cxnSp>
       <p:sp>
         <p:nvSpPr>
-          <p:cNvPr id="8" name="TextBox 7"/>
+          <p:cNvPr id="10" name="TextBox 9"/>
           <p:cNvSpPr txBox="1"/>
           <p:nvPr/>
         </p:nvSpPr>
@@ -5328,7 +6770,7 @@
       </p:sp>
       <p:sp>
         <p:nvSpPr>
-          <p:cNvPr id="9" name="TextBox 8"/>
+          <p:cNvPr id="11" name="TextBox 10"/>
           <p:cNvSpPr txBox="1"/>
           <p:nvPr/>
         </p:nvSpPr>
@@ -5554,17 +6996,813 @@
         </p:blipFill>
         <p:spPr>
           <a:xfrm>
-            <a:off x="285750" y="809625"/>
-            <a:ext cx="11620500" cy="5238750"/>
+            <a:off x="285750" y="857250"/>
+            <a:ext cx="6858000" cy="4572000"/>
           </a:xfrm>
           <a:prstGeom prst="rect">
             <a:avLst/>
           </a:prstGeom>
         </p:spPr>
       </p:pic>
+      <p:graphicFrame>
+        <p:nvGraphicFramePr>
+          <p:cNvPr id="7" name="Table 6"/>
+          <p:cNvGraphicFramePr>
+            <a:graphicFrameLocks noGrp="1"/>
+          </p:cNvGraphicFramePr>
+          <p:nvPr/>
+        </p:nvGraphicFramePr>
+        <p:xfrm>
+          <a:off x="7239000" y="1143000"/>
+          <a:ext cx="4476750" cy="3048000"/>
+        </p:xfrm>
+        <a:graphic>
+          <a:graphicData uri="http://schemas.openxmlformats.org/drawingml/2006/table">
+            <a:tbl>
+              <a:tblPr firstRow="1" bandRow="1">
+                <a:tableStyleId>{5C22544A-7EE6-4342-B048-85BDC9FD1C3A}</a:tableStyleId>
+              </a:tblPr>
+              <a:tblGrid>
+                <a:gridCol w="746125"/>
+                <a:gridCol w="746125"/>
+                <a:gridCol w="746125"/>
+                <a:gridCol w="746125"/>
+                <a:gridCol w="746125"/>
+                <a:gridCol w="746125"/>
+              </a:tblGrid>
+              <a:tr h="609600">
+                <a:tc>
+                  <a:txBody>
+                    <a:bodyPr/>
+                    <a:lstStyle/>
+                    <a:p>
+                      <a:pPr algn="ctr"/>
+                      <a:r>
+                        <a:rPr sz="1100" b="1">
+                          <a:solidFill>
+                            <a:srgbClr val="FFFFFF"/>
+                          </a:solidFill>
+                          <a:latin typeface="AppleGothic"/>
+                          <a:ea typeface="AppleGothic"/>
+                        </a:rPr>
+                        <a:t>모형</a:t>
+                      </a:r>
+                    </a:p>
+                  </a:txBody>
+                  <a:tcPr anchor="ctr">
+                    <a:solidFill>
+                      <a:srgbClr val="111111"/>
+                    </a:solidFill>
+                  </a:tcPr>
+                </a:tc>
+                <a:tc>
+                  <a:txBody>
+                    <a:bodyPr/>
+                    <a:lstStyle/>
+                    <a:p>
+                      <a:pPr algn="ctr"/>
+                      <a:r>
+                        <a:rPr sz="1100" b="1">
+                          <a:solidFill>
+                            <a:srgbClr val="FFFFFF"/>
+                          </a:solidFill>
+                          <a:latin typeface="AppleGothic"/>
+                          <a:ea typeface="AppleGothic"/>
+                        </a:rPr>
+                        <a:t>Sun</a:t>
+                      </a:r>
+                    </a:p>
+                  </a:txBody>
+                  <a:tcPr anchor="ctr">
+                    <a:solidFill>
+                      <a:srgbClr val="111111"/>
+                    </a:solidFill>
+                  </a:tcPr>
+                </a:tc>
+                <a:tc>
+                  <a:txBody>
+                    <a:bodyPr/>
+                    <a:lstStyle/>
+                    <a:p>
+                      <a:pPr algn="ctr"/>
+                      <a:r>
+                        <a:rPr sz="1100" b="1">
+                          <a:solidFill>
+                            <a:srgbClr val="FFFFFF"/>
+                          </a:solidFill>
+                          <a:latin typeface="AppleGothic"/>
+                          <a:ea typeface="AppleGothic"/>
+                        </a:rPr>
+                        <a:t>RWTH</a:t>
+                      </a:r>
+                    </a:p>
+                  </a:txBody>
+                  <a:tcPr anchor="ctr">
+                    <a:solidFill>
+                      <a:srgbClr val="111111"/>
+                    </a:solidFill>
+                  </a:tcPr>
+                </a:tc>
+                <a:tc>
+                  <a:txBody>
+                    <a:bodyPr/>
+                    <a:lstStyle/>
+                    <a:p>
+                      <a:pPr algn="ctr"/>
+                      <a:r>
+                        <a:rPr sz="1100" b="1">
+                          <a:solidFill>
+                            <a:srgbClr val="FFFFFF"/>
+                          </a:solidFill>
+                          <a:latin typeface="AppleGothic"/>
+                          <a:ea typeface="AppleGothic"/>
+                        </a:rPr>
+                        <a:t>MICH</a:t>
+                      </a:r>
+                    </a:p>
+                  </a:txBody>
+                  <a:tcPr anchor="ctr">
+                    <a:solidFill>
+                      <a:srgbClr val="111111"/>
+                    </a:solidFill>
+                  </a:tcPr>
+                </a:tc>
+                <a:tc>
+                  <a:txBody>
+                    <a:bodyPr/>
+                    <a:lstStyle/>
+                    <a:p>
+                      <a:pPr algn="ctr"/>
+                      <a:r>
+                        <a:rPr sz="1100" b="1">
+                          <a:solidFill>
+                            <a:srgbClr val="FFFFFF"/>
+                          </a:solidFill>
+                          <a:latin typeface="AppleGothic"/>
+                          <a:ea typeface="AppleGothic"/>
+                        </a:rPr>
+                        <a:t>평균</a:t>
+                      </a:r>
+                    </a:p>
+                  </a:txBody>
+                  <a:tcPr anchor="ctr">
+                    <a:solidFill>
+                      <a:srgbClr val="111111"/>
+                    </a:solidFill>
+                  </a:tcPr>
+                </a:tc>
+                <a:tc>
+                  <a:txBody>
+                    <a:bodyPr/>
+                    <a:lstStyle/>
+                    <a:p>
+                      <a:pPr algn="ctr"/>
+                      <a:r>
+                        <a:rPr sz="1100" b="1">
+                          <a:solidFill>
+                            <a:srgbClr val="FFFFFF"/>
+                          </a:solidFill>
+                          <a:latin typeface="AppleGothic"/>
+                          <a:ea typeface="AppleGothic"/>
+                        </a:rPr>
+                        <a:t>최저</a:t>
+                      </a:r>
+                    </a:p>
+                  </a:txBody>
+                  <a:tcPr anchor="ctr">
+                    <a:solidFill>
+                      <a:srgbClr val="111111"/>
+                    </a:solidFill>
+                  </a:tcPr>
+                </a:tc>
+              </a:tr>
+              <a:tr h="609600">
+                <a:tc>
+                  <a:txBody>
+                    <a:bodyPr/>
+                    <a:lstStyle/>
+                    <a:p>
+                      <a:pPr algn="l"/>
+                      <a:r>
+                        <a:rPr sz="1100" b="1">
+                          <a:solidFill>
+                            <a:srgbClr val="111111"/>
+                          </a:solidFill>
+                          <a:latin typeface="AppleGothic"/>
+                          <a:ea typeface="AppleGothic"/>
+                        </a:rPr>
+                        <a:t>고정 경계</a:t>
+                      </a:r>
+                    </a:p>
+                  </a:txBody>
+                  <a:tcPr anchor="ctr">
+                    <a:solidFill>
+                      <a:srgbClr val="FFFFFF"/>
+                    </a:solidFill>
+                  </a:tcPr>
+                </a:tc>
+                <a:tc>
+                  <a:txBody>
+                    <a:bodyPr/>
+                    <a:lstStyle/>
+                    <a:p>
+                      <a:pPr algn="ctr"/>
+                      <a:r>
+                        <a:rPr sz="1100" b="0">
+                          <a:solidFill>
+                            <a:srgbClr val="111111"/>
+                          </a:solidFill>
+                          <a:latin typeface="AppleGothic"/>
+                          <a:ea typeface="AppleGothic"/>
+                        </a:rPr>
+                        <a:t>0.939</a:t>
+                      </a:r>
+                    </a:p>
+                  </a:txBody>
+                  <a:tcPr anchor="ctr">
+                    <a:solidFill>
+                      <a:srgbClr val="FFFFFF"/>
+                    </a:solidFill>
+                  </a:tcPr>
+                </a:tc>
+                <a:tc>
+                  <a:txBody>
+                    <a:bodyPr/>
+                    <a:lstStyle/>
+                    <a:p>
+                      <a:pPr algn="l"/>
+                      <a:r>
+                        <a:rPr sz="1100" b="0">
+                          <a:solidFill>
+                            <a:srgbClr val="111111"/>
+                          </a:solidFill>
+                          <a:latin typeface="AppleGothic"/>
+                          <a:ea typeface="AppleGothic"/>
+                        </a:rPr>
+                        <a:t>0.878</a:t>
+                      </a:r>
+                    </a:p>
+                  </a:txBody>
+                  <a:tcPr anchor="ctr">
+                    <a:solidFill>
+                      <a:srgbClr val="FFFFFF"/>
+                    </a:solidFill>
+                  </a:tcPr>
+                </a:tc>
+                <a:tc>
+                  <a:txBody>
+                    <a:bodyPr/>
+                    <a:lstStyle/>
+                    <a:p>
+                      <a:pPr algn="l"/>
+                      <a:r>
+                        <a:rPr sz="1100" b="0">
+                          <a:solidFill>
+                            <a:srgbClr val="111111"/>
+                          </a:solidFill>
+                          <a:latin typeface="AppleGothic"/>
+                          <a:ea typeface="AppleGothic"/>
+                        </a:rPr>
+                        <a:t>0.468</a:t>
+                      </a:r>
+                    </a:p>
+                  </a:txBody>
+                  <a:tcPr anchor="ctr">
+                    <a:solidFill>
+                      <a:srgbClr val="FFFFFF"/>
+                    </a:solidFill>
+                  </a:tcPr>
+                </a:tc>
+                <a:tc>
+                  <a:txBody>
+                    <a:bodyPr/>
+                    <a:lstStyle/>
+                    <a:p>
+                      <a:pPr algn="ctr"/>
+                      <a:r>
+                        <a:rPr sz="1100" b="0">
+                          <a:solidFill>
+                            <a:srgbClr val="111111"/>
+                          </a:solidFill>
+                          <a:latin typeface="AppleGothic"/>
+                          <a:ea typeface="AppleGothic"/>
+                        </a:rPr>
+                        <a:t>0.762</a:t>
+                      </a:r>
+                    </a:p>
+                  </a:txBody>
+                  <a:tcPr anchor="ctr">
+                    <a:solidFill>
+                      <a:srgbClr val="FFFFFF"/>
+                    </a:solidFill>
+                  </a:tcPr>
+                </a:tc>
+                <a:tc>
+                  <a:txBody>
+                    <a:bodyPr/>
+                    <a:lstStyle/>
+                    <a:p>
+                      <a:pPr algn="ctr"/>
+                      <a:r>
+                        <a:rPr sz="1100" b="0">
+                          <a:solidFill>
+                            <a:srgbClr val="111111"/>
+                          </a:solidFill>
+                          <a:latin typeface="AppleGothic"/>
+                          <a:ea typeface="AppleGothic"/>
+                        </a:rPr>
+                        <a:t>0.468</a:t>
+                      </a:r>
+                    </a:p>
+                  </a:txBody>
+                  <a:tcPr anchor="ctr">
+                    <a:solidFill>
+                      <a:srgbClr val="FFFFFF"/>
+                    </a:solidFill>
+                  </a:tcPr>
+                </a:tc>
+              </a:tr>
+              <a:tr h="609600">
+                <a:tc>
+                  <a:txBody>
+                    <a:bodyPr/>
+                    <a:lstStyle/>
+                    <a:p>
+                      <a:pPr algn="l"/>
+                      <a:r>
+                        <a:rPr sz="1100" b="1">
+                          <a:solidFill>
+                            <a:srgbClr val="111111"/>
+                          </a:solidFill>
+                          <a:latin typeface="AppleGothic"/>
+                          <a:ea typeface="AppleGothic"/>
+                        </a:rPr>
+                        <a:t>무제한</a:t>
+                      </a:r>
+                    </a:p>
+                  </a:txBody>
+                  <a:tcPr anchor="ctr">
+                    <a:solidFill>
+                      <a:srgbClr val="F2F2F0"/>
+                    </a:solidFill>
+                  </a:tcPr>
+                </a:tc>
+                <a:tc>
+                  <a:txBody>
+                    <a:bodyPr/>
+                    <a:lstStyle/>
+                    <a:p>
+                      <a:pPr algn="ctr"/>
+                      <a:r>
+                        <a:rPr sz="1100" b="0">
+                          <a:solidFill>
+                            <a:srgbClr val="111111"/>
+                          </a:solidFill>
+                          <a:latin typeface="AppleGothic"/>
+                          <a:ea typeface="AppleGothic"/>
+                        </a:rPr>
+                        <a:t>0.718</a:t>
+                      </a:r>
+                    </a:p>
+                  </a:txBody>
+                  <a:tcPr anchor="ctr">
+                    <a:solidFill>
+                      <a:srgbClr val="F2F2F0"/>
+                    </a:solidFill>
+                  </a:tcPr>
+                </a:tc>
+                <a:tc>
+                  <a:txBody>
+                    <a:bodyPr/>
+                    <a:lstStyle/>
+                    <a:p>
+                      <a:pPr algn="l"/>
+                      <a:r>
+                        <a:rPr sz="1100" b="0">
+                          <a:solidFill>
+                            <a:srgbClr val="111111"/>
+                          </a:solidFill>
+                          <a:latin typeface="AppleGothic"/>
+                          <a:ea typeface="AppleGothic"/>
+                        </a:rPr>
+                        <a:t>0.788</a:t>
+                      </a:r>
+                    </a:p>
+                  </a:txBody>
+                  <a:tcPr anchor="ctr">
+                    <a:solidFill>
+                      <a:srgbClr val="F2F2F0"/>
+                    </a:solidFill>
+                  </a:tcPr>
+                </a:tc>
+                <a:tc>
+                  <a:txBody>
+                    <a:bodyPr/>
+                    <a:lstStyle/>
+                    <a:p>
+                      <a:pPr algn="l"/>
+                      <a:r>
+                        <a:rPr sz="1100" b="0">
+                          <a:solidFill>
+                            <a:srgbClr val="111111"/>
+                          </a:solidFill>
+                          <a:latin typeface="AppleGothic"/>
+                          <a:ea typeface="AppleGothic"/>
+                        </a:rPr>
+                        <a:t>0.759</a:t>
+                      </a:r>
+                    </a:p>
+                  </a:txBody>
+                  <a:tcPr anchor="ctr">
+                    <a:solidFill>
+                      <a:srgbClr val="F2F2F0"/>
+                    </a:solidFill>
+                  </a:tcPr>
+                </a:tc>
+                <a:tc>
+                  <a:txBody>
+                    <a:bodyPr/>
+                    <a:lstStyle/>
+                    <a:p>
+                      <a:pPr algn="ctr"/>
+                      <a:r>
+                        <a:rPr sz="1100" b="0">
+                          <a:solidFill>
+                            <a:srgbClr val="111111"/>
+                          </a:solidFill>
+                          <a:latin typeface="AppleGothic"/>
+                          <a:ea typeface="AppleGothic"/>
+                        </a:rPr>
+                        <a:t>0.755</a:t>
+                      </a:r>
+                    </a:p>
+                  </a:txBody>
+                  <a:tcPr anchor="ctr">
+                    <a:solidFill>
+                      <a:srgbClr val="F2F2F0"/>
+                    </a:solidFill>
+                  </a:tcPr>
+                </a:tc>
+                <a:tc>
+                  <a:txBody>
+                    <a:bodyPr/>
+                    <a:lstStyle/>
+                    <a:p>
+                      <a:pPr algn="ctr"/>
+                      <a:r>
+                        <a:rPr sz="1100" b="0">
+                          <a:solidFill>
+                            <a:srgbClr val="111111"/>
+                          </a:solidFill>
+                          <a:latin typeface="AppleGothic"/>
+                          <a:ea typeface="AppleGothic"/>
+                        </a:rPr>
+                        <a:t>0.718</a:t>
+                      </a:r>
+                    </a:p>
+                  </a:txBody>
+                  <a:tcPr anchor="ctr">
+                    <a:solidFill>
+                      <a:srgbClr val="F2F2F0"/>
+                    </a:solidFill>
+                  </a:tcPr>
+                </a:tc>
+              </a:tr>
+              <a:tr h="609600">
+                <a:tc>
+                  <a:txBody>
+                    <a:bodyPr/>
+                    <a:lstStyle/>
+                    <a:p>
+                      <a:pPr algn="l"/>
+                      <a:r>
+                        <a:rPr sz="1100" b="1">
+                          <a:solidFill>
+                            <a:srgbClr val="111111"/>
+                          </a:solidFill>
+                          <a:latin typeface="AppleGothic"/>
+                          <a:ea typeface="AppleGothic"/>
+                        </a:rPr>
+                        <a:t>거리보정</a:t>
+                      </a:r>
+                    </a:p>
+                  </a:txBody>
+                  <a:tcPr anchor="ctr">
+                    <a:solidFill>
+                      <a:srgbClr val="FFFFFF"/>
+                    </a:solidFill>
+                  </a:tcPr>
+                </a:tc>
+                <a:tc>
+                  <a:txBody>
+                    <a:bodyPr/>
+                    <a:lstStyle/>
+                    <a:p>
+                      <a:pPr algn="ctr"/>
+                      <a:r>
+                        <a:rPr sz="1100" b="0">
+                          <a:solidFill>
+                            <a:srgbClr val="111111"/>
+                          </a:solidFill>
+                          <a:latin typeface="AppleGothic"/>
+                          <a:ea typeface="AppleGothic"/>
+                        </a:rPr>
+                        <a:t>0.894</a:t>
+                      </a:r>
+                    </a:p>
+                  </a:txBody>
+                  <a:tcPr anchor="ctr">
+                    <a:solidFill>
+                      <a:srgbClr val="FFFFFF"/>
+                    </a:solidFill>
+                  </a:tcPr>
+                </a:tc>
+                <a:tc>
+                  <a:txBody>
+                    <a:bodyPr/>
+                    <a:lstStyle/>
+                    <a:p>
+                      <a:pPr algn="l"/>
+                      <a:r>
+                        <a:rPr sz="1100" b="0">
+                          <a:solidFill>
+                            <a:srgbClr val="111111"/>
+                          </a:solidFill>
+                          <a:latin typeface="AppleGothic"/>
+                          <a:ea typeface="AppleGothic"/>
+                        </a:rPr>
+                        <a:t>0.800</a:t>
+                      </a:r>
+                    </a:p>
+                  </a:txBody>
+                  <a:tcPr anchor="ctr">
+                    <a:solidFill>
+                      <a:srgbClr val="FFFFFF"/>
+                    </a:solidFill>
+                  </a:tcPr>
+                </a:tc>
+                <a:tc>
+                  <a:txBody>
+                    <a:bodyPr/>
+                    <a:lstStyle/>
+                    <a:p>
+                      <a:pPr algn="l"/>
+                      <a:r>
+                        <a:rPr sz="1100" b="0">
+                          <a:solidFill>
+                            <a:srgbClr val="111111"/>
+                          </a:solidFill>
+                          <a:latin typeface="AppleGothic"/>
+                          <a:ea typeface="AppleGothic"/>
+                        </a:rPr>
+                        <a:t>0.736</a:t>
+                      </a:r>
+                    </a:p>
+                  </a:txBody>
+                  <a:tcPr anchor="ctr">
+                    <a:solidFill>
+                      <a:srgbClr val="FFFFFF"/>
+                    </a:solidFill>
+                  </a:tcPr>
+                </a:tc>
+                <a:tc>
+                  <a:txBody>
+                    <a:bodyPr/>
+                    <a:lstStyle/>
+                    <a:p>
+                      <a:pPr algn="ctr"/>
+                      <a:r>
+                        <a:rPr sz="1100" b="0">
+                          <a:solidFill>
+                            <a:srgbClr val="111111"/>
+                          </a:solidFill>
+                          <a:latin typeface="AppleGothic"/>
+                          <a:ea typeface="AppleGothic"/>
+                        </a:rPr>
+                        <a:t>0.810</a:t>
+                      </a:r>
+                    </a:p>
+                  </a:txBody>
+                  <a:tcPr anchor="ctr">
+                    <a:solidFill>
+                      <a:srgbClr val="FFFFFF"/>
+                    </a:solidFill>
+                  </a:tcPr>
+                </a:tc>
+                <a:tc>
+                  <a:txBody>
+                    <a:bodyPr/>
+                    <a:lstStyle/>
+                    <a:p>
+                      <a:pPr algn="ctr"/>
+                      <a:r>
+                        <a:rPr sz="1100" b="0">
+                          <a:solidFill>
+                            <a:srgbClr val="111111"/>
+                          </a:solidFill>
+                          <a:latin typeface="AppleGothic"/>
+                          <a:ea typeface="AppleGothic"/>
+                        </a:rPr>
+                        <a:t>0.736</a:t>
+                      </a:r>
+                    </a:p>
+                  </a:txBody>
+                  <a:tcPr anchor="ctr">
+                    <a:solidFill>
+                      <a:srgbClr val="FFFFFF"/>
+                    </a:solidFill>
+                  </a:tcPr>
+                </a:tc>
+              </a:tr>
+              <a:tr h="609600">
+                <a:tc>
+                  <a:txBody>
+                    <a:bodyPr/>
+                    <a:lstStyle/>
+                    <a:p>
+                      <a:pPr algn="l"/>
+                      <a:r>
+                        <a:rPr sz="1100" b="1">
+                          <a:solidFill>
+                            <a:srgbClr val="0A5C5C"/>
+                          </a:solidFill>
+                          <a:latin typeface="AppleGothic"/>
+                          <a:ea typeface="AppleGothic"/>
+                        </a:rPr>
+                        <a:t>SAAR</a:t>
+                      </a:r>
+                    </a:p>
+                  </a:txBody>
+                  <a:tcPr anchor="ctr">
+                    <a:solidFill>
+                      <a:srgbClr val="DCEBEB"/>
+                    </a:solidFill>
+                  </a:tcPr>
+                </a:tc>
+                <a:tc>
+                  <a:txBody>
+                    <a:bodyPr/>
+                    <a:lstStyle/>
+                    <a:p>
+                      <a:pPr algn="ctr"/>
+                      <a:r>
+                        <a:rPr sz="1100" b="1">
+                          <a:solidFill>
+                            <a:srgbClr val="0A5C5C"/>
+                          </a:solidFill>
+                          <a:latin typeface="AppleGothic"/>
+                          <a:ea typeface="AppleGothic"/>
+                        </a:rPr>
+                        <a:t>0.934</a:t>
+                      </a:r>
+                    </a:p>
+                  </a:txBody>
+                  <a:tcPr anchor="ctr">
+                    <a:solidFill>
+                      <a:srgbClr val="DCEBEB"/>
+                    </a:solidFill>
+                  </a:tcPr>
+                </a:tc>
+                <a:tc>
+                  <a:txBody>
+                    <a:bodyPr/>
+                    <a:lstStyle/>
+                    <a:p>
+                      <a:pPr algn="l"/>
+                      <a:r>
+                        <a:rPr sz="1100" b="1">
+                          <a:solidFill>
+                            <a:srgbClr val="0A5C5C"/>
+                          </a:solidFill>
+                          <a:latin typeface="AppleGothic"/>
+                          <a:ea typeface="AppleGothic"/>
+                        </a:rPr>
+                        <a:t>0.842</a:t>
+                      </a:r>
+                    </a:p>
+                  </a:txBody>
+                  <a:tcPr anchor="ctr">
+                    <a:solidFill>
+                      <a:srgbClr val="DCEBEB"/>
+                    </a:solidFill>
+                  </a:tcPr>
+                </a:tc>
+                <a:tc>
+                  <a:txBody>
+                    <a:bodyPr/>
+                    <a:lstStyle/>
+                    <a:p>
+                      <a:pPr algn="l"/>
+                      <a:r>
+                        <a:rPr sz="1100" b="1">
+                          <a:solidFill>
+                            <a:srgbClr val="0A5C5C"/>
+                          </a:solidFill>
+                          <a:latin typeface="AppleGothic"/>
+                          <a:ea typeface="AppleGothic"/>
+                        </a:rPr>
+                        <a:t>0.751</a:t>
+                      </a:r>
+                    </a:p>
+                  </a:txBody>
+                  <a:tcPr anchor="ctr">
+                    <a:solidFill>
+                      <a:srgbClr val="DCEBEB"/>
+                    </a:solidFill>
+                  </a:tcPr>
+                </a:tc>
+                <a:tc>
+                  <a:txBody>
+                    <a:bodyPr/>
+                    <a:lstStyle/>
+                    <a:p>
+                      <a:pPr algn="ctr"/>
+                      <a:r>
+                        <a:rPr sz="1100" b="1">
+                          <a:solidFill>
+                            <a:srgbClr val="0A5C5C"/>
+                          </a:solidFill>
+                          <a:latin typeface="AppleGothic"/>
+                          <a:ea typeface="AppleGothic"/>
+                        </a:rPr>
+                        <a:t>0.842</a:t>
+                      </a:r>
+                    </a:p>
+                  </a:txBody>
+                  <a:tcPr anchor="ctr">
+                    <a:solidFill>
+                      <a:srgbClr val="DCEBEB"/>
+                    </a:solidFill>
+                  </a:tcPr>
+                </a:tc>
+                <a:tc>
+                  <a:txBody>
+                    <a:bodyPr/>
+                    <a:lstStyle/>
+                    <a:p>
+                      <a:pPr algn="ctr"/>
+                      <a:r>
+                        <a:rPr sz="1100" b="1">
+                          <a:solidFill>
+                            <a:srgbClr val="0A5C5C"/>
+                          </a:solidFill>
+                          <a:latin typeface="AppleGothic"/>
+                          <a:ea typeface="AppleGothic"/>
+                        </a:rPr>
+                        <a:t>0.751</a:t>
+                      </a:r>
+                    </a:p>
+                  </a:txBody>
+                  <a:tcPr anchor="ctr">
+                    <a:solidFill>
+                      <a:srgbClr val="DCEBEB"/>
+                    </a:solidFill>
+                  </a:tcPr>
+                </a:tc>
+              </a:tr>
+            </a:tbl>
+          </a:graphicData>
+        </a:graphic>
+      </p:graphicFrame>
+      <p:sp>
+        <p:nvSpPr>
+          <p:cNvPr id="8" name="TextBox 7"/>
+          <p:cNvSpPr txBox="1"/>
+          <p:nvPr/>
+        </p:nvSpPr>
+        <p:spPr>
+          <a:xfrm>
+            <a:off x="7239000" y="4381500"/>
+            <a:ext cx="4476750" cy="476250"/>
+          </a:xfrm>
+          <a:prstGeom prst="rect">
+            <a:avLst/>
+          </a:prstGeom>
+          <a:noFill/>
+        </p:spPr>
+        <p:txBody>
+          <a:bodyPr wrap="square">
+            <a:spAutoFit/>
+          </a:bodyPr>
+          <a:lstStyle/>
+          <a:p>
+            <a:pPr algn="l"/>
+            <a:r>
+              <a:rPr sz="1100" b="0">
+                <a:solidFill>
+                  <a:srgbClr val="555555"/>
+                </a:solidFill>
+                <a:latin typeface="AppleGothic"/>
+                <a:ea typeface="AppleGothic"/>
+              </a:rPr>
+              <a:t>최저(MICH)를 살린 tradeoff  ·  확증 cohort 별도</a:t>
+            </a:r>
+          </a:p>
+        </p:txBody>
+      </p:sp>
       <p:cxnSp>
         <p:nvCxnSpPr>
-          <p:cNvPr id="7" name="Connector 6"/>
+          <p:cNvPr id="9" name="Connector 8"/>
           <p:cNvCxnSpPr/>
           <p:nvPr/>
         </p:nvCxnSpPr>
@@ -5599,7 +7837,7 @@
       </p:cxnSp>
       <p:sp>
         <p:nvSpPr>
-          <p:cNvPr id="8" name="TextBox 7"/>
+          <p:cNvPr id="10" name="TextBox 9"/>
           <p:cNvSpPr txBox="1"/>
           <p:nvPr/>
         </p:nvSpPr>
@@ -5635,7 +7873,7 @@
       </p:sp>
       <p:sp>
         <p:nvSpPr>
-          <p:cNvPr id="9" name="TextBox 8"/>
+          <p:cNvPr id="11" name="TextBox 10"/>
           <p:cNvSpPr txBox="1"/>
           <p:nvPr/>
         </p:nvSpPr>
@@ -6454,7 +8692,7 @@
                 <a:latin typeface="AppleGothic"/>
                 <a:ea typeface="AppleGothic"/>
               </a:rPr>
-              <a:t>bootstrap CI  ·  MICH unit $R^2$</a:t>
+              <a:t>bootstrap CI  ·  MICH unit R²</a:t>
             </a:r>
           </a:p>
         </p:txBody>

</xml_diff>

<commit_message>
Restyle competitor comparison as a journal figure with a native table.
Replace the stacked bar summary with a colorblind-safe heatmap plus SAAR/TabPFN dot panel, export PDF/SVG, and keep exact R² values in an editable PowerPoint table.

Co-authored-by: Cursor <cursoragent@cursor.com>
</commit_message>
<xml_diff>
--- a/output/PP_Research_Detailed_v2.pptx
+++ b/output/PP_Research_Detailed_v2.pptx
@@ -8385,7 +8385,7 @@
                 <a:latin typeface="AppleGothic"/>
                 <a:ea typeface="AppleGothic"/>
               </a:rPr>
-              <a:t>양의 8곳 × 전 알고리즘 (SAAR … TabPFN 한 그래프)</a:t>
+              <a:t>(a) heatmap  ·  (b) SAAR vs TabPFN vs others  ·  아래는 동일 수치 표</a:t>
             </a:r>
           </a:p>
         </p:txBody>
@@ -8406,17 +8406,2012 @@
         </p:blipFill>
         <p:spPr>
           <a:xfrm>
-            <a:off x="381000" y="742950"/>
-            <a:ext cx="11430000" cy="5334000"/>
+            <a:off x="381000" y="781050"/>
+            <a:ext cx="11239500" cy="3429000"/>
           </a:xfrm>
           <a:prstGeom prst="rect">
             <a:avLst/>
           </a:prstGeom>
         </p:spPr>
       </p:pic>
+      <p:graphicFrame>
+        <p:nvGraphicFramePr>
+          <p:cNvPr id="7" name="Table 6"/>
+          <p:cNvGraphicFramePr>
+            <a:graphicFrameLocks noGrp="1"/>
+          </p:cNvGraphicFramePr>
+          <p:nvPr/>
+        </p:nvGraphicFramePr>
+        <p:xfrm>
+          <a:off x="381000" y="4333875"/>
+          <a:ext cx="11430000" cy="1905000"/>
+        </p:xfrm>
+        <a:graphic>
+          <a:graphicData uri="http://schemas.openxmlformats.org/drawingml/2006/table">
+            <a:tbl>
+              <a:tblPr firstRow="1" bandRow="1">
+                <a:tableStyleId>{5C22544A-7EE6-4342-B048-85BDC9FD1C3A}</a:tableStyleId>
+              </a:tblPr>
+              <a:tblGrid>
+                <a:gridCol w="1270000"/>
+                <a:gridCol w="1270000"/>
+                <a:gridCol w="1270000"/>
+                <a:gridCol w="1270000"/>
+                <a:gridCol w="1270000"/>
+                <a:gridCol w="1270000"/>
+                <a:gridCol w="1270000"/>
+                <a:gridCol w="1270000"/>
+                <a:gridCol w="1270000"/>
+              </a:tblGrid>
+              <a:tr h="211666">
+                <a:tc>
+                  <a:txBody>
+                    <a:bodyPr/>
+                    <a:lstStyle/>
+                    <a:p>
+                      <a:pPr algn="ctr"/>
+                      <a:r>
+                        <a:rPr sz="900" b="1">
+                          <a:solidFill>
+                            <a:srgbClr val="FFFFFF"/>
+                          </a:solidFill>
+                          <a:latin typeface="AppleGothic"/>
+                          <a:ea typeface="AppleGothic"/>
+                        </a:rPr>
+                        <a:t>Dataset</a:t>
+                      </a:r>
+                    </a:p>
+                  </a:txBody>
+                  <a:tcPr anchor="ctr">
+                    <a:solidFill>
+                      <a:srgbClr val="111111"/>
+                    </a:solidFill>
+                  </a:tcPr>
+                </a:tc>
+                <a:tc>
+                  <a:txBody>
+                    <a:bodyPr/>
+                    <a:lstStyle/>
+                    <a:p>
+                      <a:pPr algn="ctr"/>
+                      <a:r>
+                        <a:rPr sz="900" b="1">
+                          <a:solidFill>
+                            <a:srgbClr val="FFFFFF"/>
+                          </a:solidFill>
+                          <a:latin typeface="AppleGothic"/>
+                          <a:ea typeface="AppleGothic"/>
+                        </a:rPr>
+                        <a:t>SAAR</a:t>
+                      </a:r>
+                    </a:p>
+                  </a:txBody>
+                  <a:tcPr anchor="ctr">
+                    <a:solidFill>
+                      <a:srgbClr val="111111"/>
+                    </a:solidFill>
+                  </a:tcPr>
+                </a:tc>
+                <a:tc>
+                  <a:txBody>
+                    <a:bodyPr/>
+                    <a:lstStyle/>
+                    <a:p>
+                      <a:pPr algn="ctr"/>
+                      <a:r>
+                        <a:rPr sz="900" b="1">
+                          <a:solidFill>
+                            <a:srgbClr val="FFFFFF"/>
+                          </a:solidFill>
+                          <a:latin typeface="AppleGothic"/>
+                          <a:ea typeface="AppleGothic"/>
+                        </a:rPr>
+                        <a:t>V-REx</a:t>
+                      </a:r>
+                    </a:p>
+                  </a:txBody>
+                  <a:tcPr anchor="ctr">
+                    <a:solidFill>
+                      <a:srgbClr val="111111"/>
+                    </a:solidFill>
+                  </a:tcPr>
+                </a:tc>
+                <a:tc>
+                  <a:txBody>
+                    <a:bodyPr/>
+                    <a:lstStyle/>
+                    <a:p>
+                      <a:pPr algn="ctr"/>
+                      <a:r>
+                        <a:rPr sz="900" b="1">
+                          <a:solidFill>
+                            <a:srgbClr val="FFFFFF"/>
+                          </a:solidFill>
+                          <a:latin typeface="AppleGothic"/>
+                          <a:ea typeface="AppleGothic"/>
+                        </a:rPr>
+                        <a:t>G-DRO</a:t>
+                      </a:r>
+                    </a:p>
+                  </a:txBody>
+                  <a:tcPr anchor="ctr">
+                    <a:solidFill>
+                      <a:srgbClr val="111111"/>
+                    </a:solidFill>
+                  </a:tcPr>
+                </a:tc>
+                <a:tc>
+                  <a:txBody>
+                    <a:bodyPr/>
+                    <a:lstStyle/>
+                    <a:p>
+                      <a:pPr algn="ctr"/>
+                      <a:r>
+                        <a:rPr sz="900" b="1">
+                          <a:solidFill>
+                            <a:srgbClr val="FFFFFF"/>
+                          </a:solidFill>
+                          <a:latin typeface="AppleGothic"/>
+                          <a:ea typeface="AppleGothic"/>
+                        </a:rPr>
+                        <a:t>Mono</a:t>
+                      </a:r>
+                    </a:p>
+                  </a:txBody>
+                  <a:tcPr anchor="ctr">
+                    <a:solidFill>
+                      <a:srgbClr val="111111"/>
+                    </a:solidFill>
+                  </a:tcPr>
+                </a:tc>
+                <a:tc>
+                  <a:txBody>
+                    <a:bodyPr/>
+                    <a:lstStyle/>
+                    <a:p>
+                      <a:pPr algn="ctr"/>
+                      <a:r>
+                        <a:rPr sz="900" b="1">
+                          <a:solidFill>
+                            <a:srgbClr val="FFFFFF"/>
+                          </a:solidFill>
+                          <a:latin typeface="AppleGothic"/>
+                          <a:ea typeface="AppleGothic"/>
+                        </a:rPr>
+                        <a:t>LinRBF</a:t>
+                      </a:r>
+                    </a:p>
+                  </a:txBody>
+                  <a:tcPr anchor="ctr">
+                    <a:solidFill>
+                      <a:srgbClr val="111111"/>
+                    </a:solidFill>
+                  </a:tcPr>
+                </a:tc>
+                <a:tc>
+                  <a:txBody>
+                    <a:bodyPr/>
+                    <a:lstStyle/>
+                    <a:p>
+                      <a:pPr algn="ctr"/>
+                      <a:r>
+                        <a:rPr sz="900" b="1">
+                          <a:solidFill>
+                            <a:srgbClr val="FFFFFF"/>
+                          </a:solidFill>
+                          <a:latin typeface="AppleGothic"/>
+                          <a:ea typeface="AppleGothic"/>
+                        </a:rPr>
+                        <a:t>Engr.</a:t>
+                      </a:r>
+                    </a:p>
+                  </a:txBody>
+                  <a:tcPr anchor="ctr">
+                    <a:solidFill>
+                      <a:srgbClr val="111111"/>
+                    </a:solidFill>
+                  </a:tcPr>
+                </a:tc>
+                <a:tc>
+                  <a:txBody>
+                    <a:bodyPr/>
+                    <a:lstStyle/>
+                    <a:p>
+                      <a:pPr algn="ctr"/>
+                      <a:r>
+                        <a:rPr sz="900" b="1">
+                          <a:solidFill>
+                            <a:srgbClr val="FFFFFF"/>
+                          </a:solidFill>
+                          <a:latin typeface="AppleGothic"/>
+                          <a:ea typeface="AppleGothic"/>
+                        </a:rPr>
+                        <a:t>GP</a:t>
+                      </a:r>
+                    </a:p>
+                  </a:txBody>
+                  <a:tcPr anchor="ctr">
+                    <a:solidFill>
+                      <a:srgbClr val="111111"/>
+                    </a:solidFill>
+                  </a:tcPr>
+                </a:tc>
+                <a:tc>
+                  <a:txBody>
+                    <a:bodyPr/>
+                    <a:lstStyle/>
+                    <a:p>
+                      <a:pPr algn="ctr"/>
+                      <a:r>
+                        <a:rPr sz="900" b="1">
+                          <a:solidFill>
+                            <a:srgbClr val="FFFFFF"/>
+                          </a:solidFill>
+                          <a:latin typeface="AppleGothic"/>
+                          <a:ea typeface="AppleGothic"/>
+                        </a:rPr>
+                        <a:t>TabPFN</a:t>
+                      </a:r>
+                    </a:p>
+                  </a:txBody>
+                  <a:tcPr anchor="ctr">
+                    <a:solidFill>
+                      <a:srgbClr val="111111"/>
+                    </a:solidFill>
+                  </a:tcPr>
+                </a:tc>
+              </a:tr>
+              <a:tr h="211666">
+                <a:tc>
+                  <a:txBody>
+                    <a:bodyPr/>
+                    <a:lstStyle/>
+                    <a:p>
+                      <a:pPr algn="l"/>
+                      <a:r>
+                        <a:rPr sz="900" b="1">
+                          <a:solidFill>
+                            <a:srgbClr val="111111"/>
+                          </a:solidFill>
+                          <a:latin typeface="AppleGothic"/>
+                          <a:ea typeface="AppleGothic"/>
+                        </a:rPr>
+                        <a:t>HUST</a:t>
+                      </a:r>
+                    </a:p>
+                  </a:txBody>
+                  <a:tcPr anchor="ctr">
+                    <a:solidFill>
+                      <a:srgbClr val="FFFFFF"/>
+                    </a:solidFill>
+                  </a:tcPr>
+                </a:tc>
+                <a:tc>
+                  <a:txBody>
+                    <a:bodyPr/>
+                    <a:lstStyle/>
+                    <a:p>
+                      <a:pPr algn="ctr"/>
+                      <a:r>
+                        <a:rPr sz="900" b="0">
+                          <a:solidFill>
+                            <a:srgbClr val="111111"/>
+                          </a:solidFill>
+                          <a:latin typeface="AppleGothic"/>
+                          <a:ea typeface="AppleGothic"/>
+                        </a:rPr>
+                        <a:t>0.958</a:t>
+                      </a:r>
+                    </a:p>
+                  </a:txBody>
+                  <a:tcPr anchor="ctr">
+                    <a:solidFill>
+                      <a:srgbClr val="FFFFFF"/>
+                    </a:solidFill>
+                  </a:tcPr>
+                </a:tc>
+                <a:tc>
+                  <a:txBody>
+                    <a:bodyPr/>
+                    <a:lstStyle/>
+                    <a:p>
+                      <a:pPr algn="l"/>
+                      <a:r>
+                        <a:rPr sz="900" b="0">
+                          <a:solidFill>
+                            <a:srgbClr val="111111"/>
+                          </a:solidFill>
+                          <a:latin typeface="AppleGothic"/>
+                          <a:ea typeface="AppleGothic"/>
+                        </a:rPr>
+                        <a:t>0.809</a:t>
+                      </a:r>
+                    </a:p>
+                  </a:txBody>
+                  <a:tcPr anchor="ctr">
+                    <a:solidFill>
+                      <a:srgbClr val="FFFFFF"/>
+                    </a:solidFill>
+                  </a:tcPr>
+                </a:tc>
+                <a:tc>
+                  <a:txBody>
+                    <a:bodyPr/>
+                    <a:lstStyle/>
+                    <a:p>
+                      <a:pPr algn="l"/>
+                      <a:r>
+                        <a:rPr sz="900" b="0">
+                          <a:solidFill>
+                            <a:srgbClr val="111111"/>
+                          </a:solidFill>
+                          <a:latin typeface="AppleGothic"/>
+                          <a:ea typeface="AppleGothic"/>
+                        </a:rPr>
+                        <a:t>0.934</a:t>
+                      </a:r>
+                    </a:p>
+                  </a:txBody>
+                  <a:tcPr anchor="ctr">
+                    <a:solidFill>
+                      <a:srgbClr val="FFFFFF"/>
+                    </a:solidFill>
+                  </a:tcPr>
+                </a:tc>
+                <a:tc>
+                  <a:txBody>
+                    <a:bodyPr/>
+                    <a:lstStyle/>
+                    <a:p>
+                      <a:pPr algn="ctr"/>
+                      <a:r>
+                        <a:rPr sz="900" b="0">
+                          <a:solidFill>
+                            <a:srgbClr val="111111"/>
+                          </a:solidFill>
+                          <a:latin typeface="AppleGothic"/>
+                          <a:ea typeface="AppleGothic"/>
+                        </a:rPr>
+                        <a:t>0.822</a:t>
+                      </a:r>
+                    </a:p>
+                  </a:txBody>
+                  <a:tcPr anchor="ctr">
+                    <a:solidFill>
+                      <a:srgbClr val="FFFFFF"/>
+                    </a:solidFill>
+                  </a:tcPr>
+                </a:tc>
+                <a:tc>
+                  <a:txBody>
+                    <a:bodyPr/>
+                    <a:lstStyle/>
+                    <a:p>
+                      <a:pPr algn="ctr"/>
+                      <a:r>
+                        <a:rPr sz="900" b="0">
+                          <a:solidFill>
+                            <a:srgbClr val="111111"/>
+                          </a:solidFill>
+                          <a:latin typeface="AppleGothic"/>
+                          <a:ea typeface="AppleGothic"/>
+                        </a:rPr>
+                        <a:t>0.710</a:t>
+                      </a:r>
+                    </a:p>
+                  </a:txBody>
+                  <a:tcPr anchor="ctr">
+                    <a:solidFill>
+                      <a:srgbClr val="FFFFFF"/>
+                    </a:solidFill>
+                  </a:tcPr>
+                </a:tc>
+                <a:tc>
+                  <a:txBody>
+                    <a:bodyPr/>
+                    <a:lstStyle/>
+                    <a:p>
+                      <a:pPr algn="ctr"/>
+                      <a:r>
+                        <a:rPr sz="900" b="0">
+                          <a:solidFill>
+                            <a:srgbClr val="111111"/>
+                          </a:solidFill>
+                          <a:latin typeface="AppleGothic"/>
+                          <a:ea typeface="AppleGothic"/>
+                        </a:rPr>
+                        <a:t>0.878</a:t>
+                      </a:r>
+                    </a:p>
+                  </a:txBody>
+                  <a:tcPr anchor="ctr">
+                    <a:solidFill>
+                      <a:srgbClr val="FFFFFF"/>
+                    </a:solidFill>
+                  </a:tcPr>
+                </a:tc>
+                <a:tc>
+                  <a:txBody>
+                    <a:bodyPr/>
+                    <a:lstStyle/>
+                    <a:p>
+                      <a:pPr algn="ctr"/>
+                      <a:r>
+                        <a:rPr sz="900" b="0">
+                          <a:solidFill>
+                            <a:srgbClr val="111111"/>
+                          </a:solidFill>
+                          <a:latin typeface="AppleGothic"/>
+                          <a:ea typeface="AppleGothic"/>
+                        </a:rPr>
+                        <a:t>-0.32</a:t>
+                      </a:r>
+                    </a:p>
+                  </a:txBody>
+                  <a:tcPr anchor="ctr">
+                    <a:solidFill>
+                      <a:srgbClr val="FFFFFF"/>
+                    </a:solidFill>
+                  </a:tcPr>
+                </a:tc>
+                <a:tc>
+                  <a:txBody>
+                    <a:bodyPr/>
+                    <a:lstStyle/>
+                    <a:p>
+                      <a:pPr algn="ctr"/>
+                      <a:r>
+                        <a:rPr sz="900" b="0">
+                          <a:solidFill>
+                            <a:srgbClr val="111111"/>
+                          </a:solidFill>
+                          <a:latin typeface="AppleGothic"/>
+                          <a:ea typeface="AppleGothic"/>
+                        </a:rPr>
+                        <a:t>0.218</a:t>
+                      </a:r>
+                    </a:p>
+                  </a:txBody>
+                  <a:tcPr anchor="ctr">
+                    <a:solidFill>
+                      <a:srgbClr val="FFFFFF"/>
+                    </a:solidFill>
+                  </a:tcPr>
+                </a:tc>
+              </a:tr>
+              <a:tr h="211666">
+                <a:tc>
+                  <a:txBody>
+                    <a:bodyPr/>
+                    <a:lstStyle/>
+                    <a:p>
+                      <a:pPr algn="l"/>
+                      <a:r>
+                        <a:rPr sz="900" b="1">
+                          <a:solidFill>
+                            <a:srgbClr val="111111"/>
+                          </a:solidFill>
+                          <a:latin typeface="AppleGothic"/>
+                          <a:ea typeface="AppleGothic"/>
+                        </a:rPr>
+                        <a:t>Virkler</a:t>
+                      </a:r>
+                    </a:p>
+                  </a:txBody>
+                  <a:tcPr anchor="ctr">
+                    <a:solidFill>
+                      <a:srgbClr val="F2F2F0"/>
+                    </a:solidFill>
+                  </a:tcPr>
+                </a:tc>
+                <a:tc>
+                  <a:txBody>
+                    <a:bodyPr/>
+                    <a:lstStyle/>
+                    <a:p>
+                      <a:pPr algn="ctr"/>
+                      <a:r>
+                        <a:rPr sz="900" b="0">
+                          <a:solidFill>
+                            <a:srgbClr val="111111"/>
+                          </a:solidFill>
+                          <a:latin typeface="AppleGothic"/>
+                          <a:ea typeface="AppleGothic"/>
+                        </a:rPr>
+                        <a:t>0.888</a:t>
+                      </a:r>
+                    </a:p>
+                  </a:txBody>
+                  <a:tcPr anchor="ctr">
+                    <a:solidFill>
+                      <a:srgbClr val="F2F2F0"/>
+                    </a:solidFill>
+                  </a:tcPr>
+                </a:tc>
+                <a:tc>
+                  <a:txBody>
+                    <a:bodyPr/>
+                    <a:lstStyle/>
+                    <a:p>
+                      <a:pPr algn="l"/>
+                      <a:r>
+                        <a:rPr sz="900" b="0">
+                          <a:solidFill>
+                            <a:srgbClr val="111111"/>
+                          </a:solidFill>
+                          <a:latin typeface="AppleGothic"/>
+                          <a:ea typeface="AppleGothic"/>
+                        </a:rPr>
+                        <a:t>0.583</a:t>
+                      </a:r>
+                    </a:p>
+                  </a:txBody>
+                  <a:tcPr anchor="ctr">
+                    <a:solidFill>
+                      <a:srgbClr val="F2F2F0"/>
+                    </a:solidFill>
+                  </a:tcPr>
+                </a:tc>
+                <a:tc>
+                  <a:txBody>
+                    <a:bodyPr/>
+                    <a:lstStyle/>
+                    <a:p>
+                      <a:pPr algn="l"/>
+                      <a:r>
+                        <a:rPr sz="900" b="0">
+                          <a:solidFill>
+                            <a:srgbClr val="111111"/>
+                          </a:solidFill>
+                          <a:latin typeface="AppleGothic"/>
+                          <a:ea typeface="AppleGothic"/>
+                        </a:rPr>
+                        <a:t>0.554</a:t>
+                      </a:r>
+                    </a:p>
+                  </a:txBody>
+                  <a:tcPr anchor="ctr">
+                    <a:solidFill>
+                      <a:srgbClr val="F2F2F0"/>
+                    </a:solidFill>
+                  </a:tcPr>
+                </a:tc>
+                <a:tc>
+                  <a:txBody>
+                    <a:bodyPr/>
+                    <a:lstStyle/>
+                    <a:p>
+                      <a:pPr algn="ctr"/>
+                      <a:r>
+                        <a:rPr sz="900" b="0">
+                          <a:solidFill>
+                            <a:srgbClr val="111111"/>
+                          </a:solidFill>
+                          <a:latin typeface="AppleGothic"/>
+                          <a:ea typeface="AppleGothic"/>
+                        </a:rPr>
+                        <a:t>0.565</a:t>
+                      </a:r>
+                    </a:p>
+                  </a:txBody>
+                  <a:tcPr anchor="ctr">
+                    <a:solidFill>
+                      <a:srgbClr val="F2F2F0"/>
+                    </a:solidFill>
+                  </a:tcPr>
+                </a:tc>
+                <a:tc>
+                  <a:txBody>
+                    <a:bodyPr/>
+                    <a:lstStyle/>
+                    <a:p>
+                      <a:pPr algn="ctr"/>
+                      <a:r>
+                        <a:rPr sz="900" b="0">
+                          <a:solidFill>
+                            <a:srgbClr val="111111"/>
+                          </a:solidFill>
+                          <a:latin typeface="AppleGothic"/>
+                          <a:ea typeface="AppleGothic"/>
+                        </a:rPr>
+                        <a:t>0.805</a:t>
+                      </a:r>
+                    </a:p>
+                  </a:txBody>
+                  <a:tcPr anchor="ctr">
+                    <a:solidFill>
+                      <a:srgbClr val="F2F2F0"/>
+                    </a:solidFill>
+                  </a:tcPr>
+                </a:tc>
+                <a:tc>
+                  <a:txBody>
+                    <a:bodyPr/>
+                    <a:lstStyle/>
+                    <a:p>
+                      <a:pPr algn="ctr"/>
+                      <a:r>
+                        <a:rPr sz="900" b="0">
+                          <a:solidFill>
+                            <a:srgbClr val="111111"/>
+                          </a:solidFill>
+                          <a:latin typeface="AppleGothic"/>
+                          <a:ea typeface="AppleGothic"/>
+                        </a:rPr>
+                        <a:t>0.552</a:t>
+                      </a:r>
+                    </a:p>
+                  </a:txBody>
+                  <a:tcPr anchor="ctr">
+                    <a:solidFill>
+                      <a:srgbClr val="F2F2F0"/>
+                    </a:solidFill>
+                  </a:tcPr>
+                </a:tc>
+                <a:tc>
+                  <a:txBody>
+                    <a:bodyPr/>
+                    <a:lstStyle/>
+                    <a:p>
+                      <a:pPr algn="ctr"/>
+                      <a:r>
+                        <a:rPr sz="900" b="0">
+                          <a:solidFill>
+                            <a:srgbClr val="111111"/>
+                          </a:solidFill>
+                          <a:latin typeface="AppleGothic"/>
+                          <a:ea typeface="AppleGothic"/>
+                        </a:rPr>
+                        <a:t>0.54</a:t>
+                      </a:r>
+                    </a:p>
+                  </a:txBody>
+                  <a:tcPr anchor="ctr">
+                    <a:solidFill>
+                      <a:srgbClr val="F2F2F0"/>
+                    </a:solidFill>
+                  </a:tcPr>
+                </a:tc>
+                <a:tc>
+                  <a:txBody>
+                    <a:bodyPr/>
+                    <a:lstStyle/>
+                    <a:p>
+                      <a:pPr algn="ctr"/>
+                      <a:r>
+                        <a:rPr sz="900" b="0">
+                          <a:solidFill>
+                            <a:srgbClr val="111111"/>
+                          </a:solidFill>
+                          <a:latin typeface="AppleGothic"/>
+                          <a:ea typeface="AppleGothic"/>
+                        </a:rPr>
+                        <a:t>0.621</a:t>
+                      </a:r>
+                    </a:p>
+                  </a:txBody>
+                  <a:tcPr anchor="ctr">
+                    <a:solidFill>
+                      <a:srgbClr val="F2F2F0"/>
+                    </a:solidFill>
+                  </a:tcPr>
+                </a:tc>
+              </a:tr>
+              <a:tr h="211666">
+                <a:tc>
+                  <a:txBody>
+                    <a:bodyPr/>
+                    <a:lstStyle/>
+                    <a:p>
+                      <a:pPr algn="l"/>
+                      <a:r>
+                        <a:rPr sz="900" b="1">
+                          <a:solidFill>
+                            <a:srgbClr val="111111"/>
+                          </a:solidFill>
+                          <a:latin typeface="AppleGothic"/>
+                          <a:ea typeface="AppleGothic"/>
+                        </a:rPr>
+                        <a:t>NASA</a:t>
+                      </a:r>
+                    </a:p>
+                  </a:txBody>
+                  <a:tcPr anchor="ctr">
+                    <a:solidFill>
+                      <a:srgbClr val="FFFFFF"/>
+                    </a:solidFill>
+                  </a:tcPr>
+                </a:tc>
+                <a:tc>
+                  <a:txBody>
+                    <a:bodyPr/>
+                    <a:lstStyle/>
+                    <a:p>
+                      <a:pPr algn="ctr"/>
+                      <a:r>
+                        <a:rPr sz="900" b="0">
+                          <a:solidFill>
+                            <a:srgbClr val="111111"/>
+                          </a:solidFill>
+                          <a:latin typeface="AppleGothic"/>
+                          <a:ea typeface="AppleGothic"/>
+                        </a:rPr>
+                        <a:t>0.584</a:t>
+                      </a:r>
+                    </a:p>
+                  </a:txBody>
+                  <a:tcPr anchor="ctr">
+                    <a:solidFill>
+                      <a:srgbClr val="FFFFFF"/>
+                    </a:solidFill>
+                  </a:tcPr>
+                </a:tc>
+                <a:tc>
+                  <a:txBody>
+                    <a:bodyPr/>
+                    <a:lstStyle/>
+                    <a:p>
+                      <a:pPr algn="l"/>
+                      <a:r>
+                        <a:rPr sz="900" b="0">
+                          <a:solidFill>
+                            <a:srgbClr val="111111"/>
+                          </a:solidFill>
+                          <a:latin typeface="AppleGothic"/>
+                          <a:ea typeface="AppleGothic"/>
+                        </a:rPr>
+                        <a:t>0.285</a:t>
+                      </a:r>
+                    </a:p>
+                  </a:txBody>
+                  <a:tcPr anchor="ctr">
+                    <a:solidFill>
+                      <a:srgbClr val="FFFFFF"/>
+                    </a:solidFill>
+                  </a:tcPr>
+                </a:tc>
+                <a:tc>
+                  <a:txBody>
+                    <a:bodyPr/>
+                    <a:lstStyle/>
+                    <a:p>
+                      <a:pPr algn="l"/>
+                      <a:r>
+                        <a:rPr sz="900" b="0">
+                          <a:solidFill>
+                            <a:srgbClr val="111111"/>
+                          </a:solidFill>
+                          <a:latin typeface="AppleGothic"/>
+                          <a:ea typeface="AppleGothic"/>
+                        </a:rPr>
+                        <a:t>0.286</a:t>
+                      </a:r>
+                    </a:p>
+                  </a:txBody>
+                  <a:tcPr anchor="ctr">
+                    <a:solidFill>
+                      <a:srgbClr val="FFFFFF"/>
+                    </a:solidFill>
+                  </a:tcPr>
+                </a:tc>
+                <a:tc>
+                  <a:txBody>
+                    <a:bodyPr/>
+                    <a:lstStyle/>
+                    <a:p>
+                      <a:pPr algn="ctr"/>
+                      <a:r>
+                        <a:rPr sz="900" b="0">
+                          <a:solidFill>
+                            <a:srgbClr val="111111"/>
+                          </a:solidFill>
+                          <a:latin typeface="AppleGothic"/>
+                          <a:ea typeface="AppleGothic"/>
+                        </a:rPr>
+                        <a:t>0.283</a:t>
+                      </a:r>
+                    </a:p>
+                  </a:txBody>
+                  <a:tcPr anchor="ctr">
+                    <a:solidFill>
+                      <a:srgbClr val="FFFFFF"/>
+                    </a:solidFill>
+                  </a:tcPr>
+                </a:tc>
+                <a:tc>
+                  <a:txBody>
+                    <a:bodyPr/>
+                    <a:lstStyle/>
+                    <a:p>
+                      <a:pPr algn="ctr"/>
+                      <a:r>
+                        <a:rPr sz="900" b="0">
+                          <a:solidFill>
+                            <a:srgbClr val="111111"/>
+                          </a:solidFill>
+                          <a:latin typeface="AppleGothic"/>
+                          <a:ea typeface="AppleGothic"/>
+                        </a:rPr>
+                        <a:t>0.550</a:t>
+                      </a:r>
+                    </a:p>
+                  </a:txBody>
+                  <a:tcPr anchor="ctr">
+                    <a:solidFill>
+                      <a:srgbClr val="FFFFFF"/>
+                    </a:solidFill>
+                  </a:tcPr>
+                </a:tc>
+                <a:tc>
+                  <a:txBody>
+                    <a:bodyPr/>
+                    <a:lstStyle/>
+                    <a:p>
+                      <a:pPr algn="ctr"/>
+                      <a:r>
+                        <a:rPr sz="900" b="0">
+                          <a:solidFill>
+                            <a:srgbClr val="111111"/>
+                          </a:solidFill>
+                          <a:latin typeface="AppleGothic"/>
+                          <a:ea typeface="AppleGothic"/>
+                        </a:rPr>
+                        <a:t>0.549</a:t>
+                      </a:r>
+                    </a:p>
+                  </a:txBody>
+                  <a:tcPr anchor="ctr">
+                    <a:solidFill>
+                      <a:srgbClr val="FFFFFF"/>
+                    </a:solidFill>
+                  </a:tcPr>
+                </a:tc>
+                <a:tc>
+                  <a:txBody>
+                    <a:bodyPr/>
+                    <a:lstStyle/>
+                    <a:p>
+                      <a:pPr algn="ctr"/>
+                      <a:r>
+                        <a:rPr sz="900" b="0">
+                          <a:solidFill>
+                            <a:srgbClr val="111111"/>
+                          </a:solidFill>
+                          <a:latin typeface="AppleGothic"/>
+                          <a:ea typeface="AppleGothic"/>
+                        </a:rPr>
+                        <a:t>0.44</a:t>
+                      </a:r>
+                    </a:p>
+                  </a:txBody>
+                  <a:tcPr anchor="ctr">
+                    <a:solidFill>
+                      <a:srgbClr val="FFFFFF"/>
+                    </a:solidFill>
+                  </a:tcPr>
+                </a:tc>
+                <a:tc>
+                  <a:txBody>
+                    <a:bodyPr/>
+                    <a:lstStyle/>
+                    <a:p>
+                      <a:pPr algn="ctr"/>
+                      <a:r>
+                        <a:rPr sz="900" b="0">
+                          <a:solidFill>
+                            <a:srgbClr val="111111"/>
+                          </a:solidFill>
+                          <a:latin typeface="AppleGothic"/>
+                          <a:ea typeface="AppleGothic"/>
+                        </a:rPr>
+                        <a:t>-0.69</a:t>
+                      </a:r>
+                    </a:p>
+                  </a:txBody>
+                  <a:tcPr anchor="ctr">
+                    <a:solidFill>
+                      <a:srgbClr val="FFFFFF"/>
+                    </a:solidFill>
+                  </a:tcPr>
+                </a:tc>
+              </a:tr>
+              <a:tr h="211666">
+                <a:tc>
+                  <a:txBody>
+                    <a:bodyPr/>
+                    <a:lstStyle/>
+                    <a:p>
+                      <a:pPr algn="l"/>
+                      <a:r>
+                        <a:rPr sz="900" b="1">
+                          <a:solidFill>
+                            <a:srgbClr val="111111"/>
+                          </a:solidFill>
+                          <a:latin typeface="AppleGothic"/>
+                          <a:ea typeface="AppleGothic"/>
+                        </a:rPr>
+                        <a:t>Sunwoda</a:t>
+                      </a:r>
+                    </a:p>
+                  </a:txBody>
+                  <a:tcPr anchor="ctr">
+                    <a:solidFill>
+                      <a:srgbClr val="F2F2F0"/>
+                    </a:solidFill>
+                  </a:tcPr>
+                </a:tc>
+                <a:tc>
+                  <a:txBody>
+                    <a:bodyPr/>
+                    <a:lstStyle/>
+                    <a:p>
+                      <a:pPr algn="ctr"/>
+                      <a:r>
+                        <a:rPr sz="900" b="0">
+                          <a:solidFill>
+                            <a:srgbClr val="111111"/>
+                          </a:solidFill>
+                          <a:latin typeface="AppleGothic"/>
+                          <a:ea typeface="AppleGothic"/>
+                        </a:rPr>
+                        <a:t>0.865</a:t>
+                      </a:r>
+                    </a:p>
+                  </a:txBody>
+                  <a:tcPr anchor="ctr">
+                    <a:solidFill>
+                      <a:srgbClr val="F2F2F0"/>
+                    </a:solidFill>
+                  </a:tcPr>
+                </a:tc>
+                <a:tc>
+                  <a:txBody>
+                    <a:bodyPr/>
+                    <a:lstStyle/>
+                    <a:p>
+                      <a:pPr algn="l"/>
+                      <a:r>
+                        <a:rPr sz="900" b="0">
+                          <a:solidFill>
+                            <a:srgbClr val="111111"/>
+                          </a:solidFill>
+                          <a:latin typeface="AppleGothic"/>
+                          <a:ea typeface="AppleGothic"/>
+                        </a:rPr>
+                        <a:t>-0.24</a:t>
+                      </a:r>
+                    </a:p>
+                  </a:txBody>
+                  <a:tcPr anchor="ctr">
+                    <a:solidFill>
+                      <a:srgbClr val="F2F2F0"/>
+                    </a:solidFill>
+                  </a:tcPr>
+                </a:tc>
+                <a:tc>
+                  <a:txBody>
+                    <a:bodyPr/>
+                    <a:lstStyle/>
+                    <a:p>
+                      <a:pPr algn="l"/>
+                      <a:r>
+                        <a:rPr sz="900" b="0">
+                          <a:solidFill>
+                            <a:srgbClr val="111111"/>
+                          </a:solidFill>
+                          <a:latin typeface="AppleGothic"/>
+                          <a:ea typeface="AppleGothic"/>
+                        </a:rPr>
+                        <a:t>-0.30</a:t>
+                      </a:r>
+                    </a:p>
+                  </a:txBody>
+                  <a:tcPr anchor="ctr">
+                    <a:solidFill>
+                      <a:srgbClr val="F2F2F0"/>
+                    </a:solidFill>
+                  </a:tcPr>
+                </a:tc>
+                <a:tc>
+                  <a:txBody>
+                    <a:bodyPr/>
+                    <a:lstStyle/>
+                    <a:p>
+                      <a:pPr algn="ctr"/>
+                      <a:r>
+                        <a:rPr sz="900" b="0">
+                          <a:solidFill>
+                            <a:srgbClr val="111111"/>
+                          </a:solidFill>
+                          <a:latin typeface="AppleGothic"/>
+                          <a:ea typeface="AppleGothic"/>
+                        </a:rPr>
+                        <a:t>-0.05</a:t>
+                      </a:r>
+                    </a:p>
+                  </a:txBody>
+                  <a:tcPr anchor="ctr">
+                    <a:solidFill>
+                      <a:srgbClr val="F2F2F0"/>
+                    </a:solidFill>
+                  </a:tcPr>
+                </a:tc>
+                <a:tc>
+                  <a:txBody>
+                    <a:bodyPr/>
+                    <a:lstStyle/>
+                    <a:p>
+                      <a:pPr algn="ctr"/>
+                      <a:r>
+                        <a:rPr sz="900" b="0">
+                          <a:solidFill>
+                            <a:srgbClr val="111111"/>
+                          </a:solidFill>
+                          <a:latin typeface="AppleGothic"/>
+                          <a:ea typeface="AppleGothic"/>
+                        </a:rPr>
+                        <a:t>0.838</a:t>
+                      </a:r>
+                    </a:p>
+                  </a:txBody>
+                  <a:tcPr anchor="ctr">
+                    <a:solidFill>
+                      <a:srgbClr val="F2F2F0"/>
+                    </a:solidFill>
+                  </a:tcPr>
+                </a:tc>
+                <a:tc>
+                  <a:txBody>
+                    <a:bodyPr/>
+                    <a:lstStyle/>
+                    <a:p>
+                      <a:pPr algn="ctr"/>
+                      <a:r>
+                        <a:rPr sz="900" b="0">
+                          <a:solidFill>
+                            <a:srgbClr val="111111"/>
+                          </a:solidFill>
+                          <a:latin typeface="AppleGothic"/>
+                          <a:ea typeface="AppleGothic"/>
+                        </a:rPr>
+                        <a:t>0.619</a:t>
+                      </a:r>
+                    </a:p>
+                  </a:txBody>
+                  <a:tcPr anchor="ctr">
+                    <a:solidFill>
+                      <a:srgbClr val="F2F2F0"/>
+                    </a:solidFill>
+                  </a:tcPr>
+                </a:tc>
+                <a:tc>
+                  <a:txBody>
+                    <a:bodyPr/>
+                    <a:lstStyle/>
+                    <a:p>
+                      <a:pPr algn="ctr"/>
+                      <a:r>
+                        <a:rPr sz="900" b="0">
+                          <a:solidFill>
+                            <a:srgbClr val="111111"/>
+                          </a:solidFill>
+                          <a:latin typeface="AppleGothic"/>
+                          <a:ea typeface="AppleGothic"/>
+                        </a:rPr>
+                        <a:t>-1.60</a:t>
+                      </a:r>
+                    </a:p>
+                  </a:txBody>
+                  <a:tcPr anchor="ctr">
+                    <a:solidFill>
+                      <a:srgbClr val="F2F2F0"/>
+                    </a:solidFill>
+                  </a:tcPr>
+                </a:tc>
+                <a:tc>
+                  <a:txBody>
+                    <a:bodyPr/>
+                    <a:lstStyle/>
+                    <a:p>
+                      <a:pPr algn="ctr"/>
+                      <a:r>
+                        <a:rPr sz="900" b="0">
+                          <a:solidFill>
+                            <a:srgbClr val="111111"/>
+                          </a:solidFill>
+                          <a:latin typeface="AppleGothic"/>
+                          <a:ea typeface="AppleGothic"/>
+                        </a:rPr>
+                        <a:t>-0.89</a:t>
+                      </a:r>
+                    </a:p>
+                  </a:txBody>
+                  <a:tcPr anchor="ctr">
+                    <a:solidFill>
+                      <a:srgbClr val="F2F2F0"/>
+                    </a:solidFill>
+                  </a:tcPr>
+                </a:tc>
+              </a:tr>
+              <a:tr h="211666">
+                <a:tc>
+                  <a:txBody>
+                    <a:bodyPr/>
+                    <a:lstStyle/>
+                    <a:p>
+                      <a:pPr algn="l"/>
+                      <a:r>
+                        <a:rPr sz="900" b="1">
+                          <a:solidFill>
+                            <a:srgbClr val="111111"/>
+                          </a:solidFill>
+                          <a:latin typeface="AppleGothic"/>
+                          <a:ea typeface="AppleGothic"/>
+                        </a:rPr>
+                        <a:t>RWTH</a:t>
+                      </a:r>
+                    </a:p>
+                  </a:txBody>
+                  <a:tcPr anchor="ctr">
+                    <a:solidFill>
+                      <a:srgbClr val="FFFFFF"/>
+                    </a:solidFill>
+                  </a:tcPr>
+                </a:tc>
+                <a:tc>
+                  <a:txBody>
+                    <a:bodyPr/>
+                    <a:lstStyle/>
+                    <a:p>
+                      <a:pPr algn="ctr"/>
+                      <a:r>
+                        <a:rPr sz="900" b="0">
+                          <a:solidFill>
+                            <a:srgbClr val="111111"/>
+                          </a:solidFill>
+                          <a:latin typeface="AppleGothic"/>
+                          <a:ea typeface="AppleGothic"/>
+                        </a:rPr>
+                        <a:t>0.743</a:t>
+                      </a:r>
+                    </a:p>
+                  </a:txBody>
+                  <a:tcPr anchor="ctr">
+                    <a:solidFill>
+                      <a:srgbClr val="FFFFFF"/>
+                    </a:solidFill>
+                  </a:tcPr>
+                </a:tc>
+                <a:tc>
+                  <a:txBody>
+                    <a:bodyPr/>
+                    <a:lstStyle/>
+                    <a:p>
+                      <a:pPr algn="l"/>
+                      <a:r>
+                        <a:rPr sz="900" b="0">
+                          <a:solidFill>
+                            <a:srgbClr val="111111"/>
+                          </a:solidFill>
+                          <a:latin typeface="AppleGothic"/>
+                          <a:ea typeface="AppleGothic"/>
+                        </a:rPr>
+                        <a:t>0.645</a:t>
+                      </a:r>
+                    </a:p>
+                  </a:txBody>
+                  <a:tcPr anchor="ctr">
+                    <a:solidFill>
+                      <a:srgbClr val="FFFFFF"/>
+                    </a:solidFill>
+                  </a:tcPr>
+                </a:tc>
+                <a:tc>
+                  <a:txBody>
+                    <a:bodyPr/>
+                    <a:lstStyle/>
+                    <a:p>
+                      <a:pPr algn="l"/>
+                      <a:r>
+                        <a:rPr sz="900" b="0">
+                          <a:solidFill>
+                            <a:srgbClr val="111111"/>
+                          </a:solidFill>
+                          <a:latin typeface="AppleGothic"/>
+                          <a:ea typeface="AppleGothic"/>
+                        </a:rPr>
+                        <a:t>0.602</a:t>
+                      </a:r>
+                    </a:p>
+                  </a:txBody>
+                  <a:tcPr anchor="ctr">
+                    <a:solidFill>
+                      <a:srgbClr val="FFFFFF"/>
+                    </a:solidFill>
+                  </a:tcPr>
+                </a:tc>
+                <a:tc>
+                  <a:txBody>
+                    <a:bodyPr/>
+                    <a:lstStyle/>
+                    <a:p>
+                      <a:pPr algn="ctr"/>
+                      <a:r>
+                        <a:rPr sz="900" b="0">
+                          <a:solidFill>
+                            <a:srgbClr val="111111"/>
+                          </a:solidFill>
+                          <a:latin typeface="AppleGothic"/>
+                          <a:ea typeface="AppleGothic"/>
+                        </a:rPr>
+                        <a:t>-0.01</a:t>
+                      </a:r>
+                    </a:p>
+                  </a:txBody>
+                  <a:tcPr anchor="ctr">
+                    <a:solidFill>
+                      <a:srgbClr val="FFFFFF"/>
+                    </a:solidFill>
+                  </a:tcPr>
+                </a:tc>
+                <a:tc>
+                  <a:txBody>
+                    <a:bodyPr/>
+                    <a:lstStyle/>
+                    <a:p>
+                      <a:pPr algn="ctr"/>
+                      <a:r>
+                        <a:rPr sz="900" b="0">
+                          <a:solidFill>
+                            <a:srgbClr val="111111"/>
+                          </a:solidFill>
+                          <a:latin typeface="AppleGothic"/>
+                          <a:ea typeface="AppleGothic"/>
+                        </a:rPr>
+                        <a:t>0.385</a:t>
+                      </a:r>
+                    </a:p>
+                  </a:txBody>
+                  <a:tcPr anchor="ctr">
+                    <a:solidFill>
+                      <a:srgbClr val="FFFFFF"/>
+                    </a:solidFill>
+                  </a:tcPr>
+                </a:tc>
+                <a:tc>
+                  <a:txBody>
+                    <a:bodyPr/>
+                    <a:lstStyle/>
+                    <a:p>
+                      <a:pPr algn="ctr"/>
+                      <a:r>
+                        <a:rPr sz="900" b="0">
+                          <a:solidFill>
+                            <a:srgbClr val="111111"/>
+                          </a:solidFill>
+                          <a:latin typeface="AppleGothic"/>
+                          <a:ea typeface="AppleGothic"/>
+                        </a:rPr>
+                        <a:t>0.526</a:t>
+                      </a:r>
+                    </a:p>
+                  </a:txBody>
+                  <a:tcPr anchor="ctr">
+                    <a:solidFill>
+                      <a:srgbClr val="FFFFFF"/>
+                    </a:solidFill>
+                  </a:tcPr>
+                </a:tc>
+                <a:tc>
+                  <a:txBody>
+                    <a:bodyPr/>
+                    <a:lstStyle/>
+                    <a:p>
+                      <a:pPr algn="ctr"/>
+                      <a:r>
+                        <a:rPr sz="900" b="0">
+                          <a:solidFill>
+                            <a:srgbClr val="111111"/>
+                          </a:solidFill>
+                          <a:latin typeface="AppleGothic"/>
+                          <a:ea typeface="AppleGothic"/>
+                        </a:rPr>
+                        <a:t>-0.47</a:t>
+                      </a:r>
+                    </a:p>
+                  </a:txBody>
+                  <a:tcPr anchor="ctr">
+                    <a:solidFill>
+                      <a:srgbClr val="FFFFFF"/>
+                    </a:solidFill>
+                  </a:tcPr>
+                </a:tc>
+                <a:tc>
+                  <a:txBody>
+                    <a:bodyPr/>
+                    <a:lstStyle/>
+                    <a:p>
+                      <a:pPr algn="ctr"/>
+                      <a:r>
+                        <a:rPr sz="900" b="0">
+                          <a:solidFill>
+                            <a:srgbClr val="111111"/>
+                          </a:solidFill>
+                          <a:latin typeface="AppleGothic"/>
+                          <a:ea typeface="AppleGothic"/>
+                        </a:rPr>
+                        <a:t>-2.18</a:t>
+                      </a:r>
+                    </a:p>
+                  </a:txBody>
+                  <a:tcPr anchor="ctr">
+                    <a:solidFill>
+                      <a:srgbClr val="FFFFFF"/>
+                    </a:solidFill>
+                  </a:tcPr>
+                </a:tc>
+              </a:tr>
+              <a:tr h="211666">
+                <a:tc>
+                  <a:txBody>
+                    <a:bodyPr/>
+                    <a:lstStyle/>
+                    <a:p>
+                      <a:pPr algn="l"/>
+                      <a:r>
+                        <a:rPr sz="900" b="1">
+                          <a:solidFill>
+                            <a:srgbClr val="111111"/>
+                          </a:solidFill>
+                          <a:latin typeface="AppleGothic"/>
+                          <a:ea typeface="AppleGothic"/>
+                        </a:rPr>
+                        <a:t>MATR19</a:t>
+                      </a:r>
+                    </a:p>
+                  </a:txBody>
+                  <a:tcPr anchor="ctr">
+                    <a:solidFill>
+                      <a:srgbClr val="F2F2F0"/>
+                    </a:solidFill>
+                  </a:tcPr>
+                </a:tc>
+                <a:tc>
+                  <a:txBody>
+                    <a:bodyPr/>
+                    <a:lstStyle/>
+                    <a:p>
+                      <a:pPr algn="ctr"/>
+                      <a:r>
+                        <a:rPr sz="900" b="0">
+                          <a:solidFill>
+                            <a:srgbClr val="111111"/>
+                          </a:solidFill>
+                          <a:latin typeface="AppleGothic"/>
+                          <a:ea typeface="AppleGothic"/>
+                        </a:rPr>
+                        <a:t>0.466</a:t>
+                      </a:r>
+                    </a:p>
+                  </a:txBody>
+                  <a:tcPr anchor="ctr">
+                    <a:solidFill>
+                      <a:srgbClr val="F2F2F0"/>
+                    </a:solidFill>
+                  </a:tcPr>
+                </a:tc>
+                <a:tc>
+                  <a:txBody>
+                    <a:bodyPr/>
+                    <a:lstStyle/>
+                    <a:p>
+                      <a:pPr algn="l"/>
+                      <a:r>
+                        <a:rPr sz="900" b="0">
+                          <a:solidFill>
+                            <a:srgbClr val="111111"/>
+                          </a:solidFill>
+                          <a:latin typeface="AppleGothic"/>
+                          <a:ea typeface="AppleGothic"/>
+                        </a:rPr>
+                        <a:t>0.044</a:t>
+                      </a:r>
+                    </a:p>
+                  </a:txBody>
+                  <a:tcPr anchor="ctr">
+                    <a:solidFill>
+                      <a:srgbClr val="F2F2F0"/>
+                    </a:solidFill>
+                  </a:tcPr>
+                </a:tc>
+                <a:tc>
+                  <a:txBody>
+                    <a:bodyPr/>
+                    <a:lstStyle/>
+                    <a:p>
+                      <a:pPr algn="l"/>
+                      <a:r>
+                        <a:rPr sz="900" b="0">
+                          <a:solidFill>
+                            <a:srgbClr val="111111"/>
+                          </a:solidFill>
+                          <a:latin typeface="AppleGothic"/>
+                          <a:ea typeface="AppleGothic"/>
+                        </a:rPr>
+                        <a:t>0.272</a:t>
+                      </a:r>
+                    </a:p>
+                  </a:txBody>
+                  <a:tcPr anchor="ctr">
+                    <a:solidFill>
+                      <a:srgbClr val="F2F2F0"/>
+                    </a:solidFill>
+                  </a:tcPr>
+                </a:tc>
+                <a:tc>
+                  <a:txBody>
+                    <a:bodyPr/>
+                    <a:lstStyle/>
+                    <a:p>
+                      <a:pPr algn="ctr"/>
+                      <a:r>
+                        <a:rPr sz="900" b="0">
+                          <a:solidFill>
+                            <a:srgbClr val="111111"/>
+                          </a:solidFill>
+                          <a:latin typeface="AppleGothic"/>
+                          <a:ea typeface="AppleGothic"/>
+                        </a:rPr>
+                        <a:t>0.018</a:t>
+                      </a:r>
+                    </a:p>
+                  </a:txBody>
+                  <a:tcPr anchor="ctr">
+                    <a:solidFill>
+                      <a:srgbClr val="F2F2F0"/>
+                    </a:solidFill>
+                  </a:tcPr>
+                </a:tc>
+                <a:tc>
+                  <a:txBody>
+                    <a:bodyPr/>
+                    <a:lstStyle/>
+                    <a:p>
+                      <a:pPr algn="ctr"/>
+                      <a:r>
+                        <a:rPr sz="900" b="0">
+                          <a:solidFill>
+                            <a:srgbClr val="111111"/>
+                          </a:solidFill>
+                          <a:latin typeface="AppleGothic"/>
+                          <a:ea typeface="AppleGothic"/>
+                        </a:rPr>
+                        <a:t>-2.64</a:t>
+                      </a:r>
+                    </a:p>
+                  </a:txBody>
+                  <a:tcPr anchor="ctr">
+                    <a:solidFill>
+                      <a:srgbClr val="F2F2F0"/>
+                    </a:solidFill>
+                  </a:tcPr>
+                </a:tc>
+                <a:tc>
+                  <a:txBody>
+                    <a:bodyPr/>
+                    <a:lstStyle/>
+                    <a:p>
+                      <a:pPr algn="ctr"/>
+                      <a:r>
+                        <a:rPr sz="900" b="0">
+                          <a:solidFill>
+                            <a:srgbClr val="111111"/>
+                          </a:solidFill>
+                          <a:latin typeface="AppleGothic"/>
+                          <a:ea typeface="AppleGothic"/>
+                        </a:rPr>
+                        <a:t>-0.73</a:t>
+                      </a:r>
+                    </a:p>
+                  </a:txBody>
+                  <a:tcPr anchor="ctr">
+                    <a:solidFill>
+                      <a:srgbClr val="F2F2F0"/>
+                    </a:solidFill>
+                  </a:tcPr>
+                </a:tc>
+                <a:tc>
+                  <a:txBody>
+                    <a:bodyPr/>
+                    <a:lstStyle/>
+                    <a:p>
+                      <a:pPr algn="ctr"/>
+                      <a:r>
+                        <a:rPr sz="900" b="0">
+                          <a:solidFill>
+                            <a:srgbClr val="111111"/>
+                          </a:solidFill>
+                          <a:latin typeface="AppleGothic"/>
+                          <a:ea typeface="AppleGothic"/>
+                        </a:rPr>
+                        <a:t>-2.46</a:t>
+                      </a:r>
+                    </a:p>
+                  </a:txBody>
+                  <a:tcPr anchor="ctr">
+                    <a:solidFill>
+                      <a:srgbClr val="F2F2F0"/>
+                    </a:solidFill>
+                  </a:tcPr>
+                </a:tc>
+                <a:tc>
+                  <a:txBody>
+                    <a:bodyPr/>
+                    <a:lstStyle/>
+                    <a:p>
+                      <a:pPr algn="ctr"/>
+                      <a:r>
+                        <a:rPr sz="900" b="0">
+                          <a:solidFill>
+                            <a:srgbClr val="111111"/>
+                          </a:solidFill>
+                          <a:latin typeface="AppleGothic"/>
+                          <a:ea typeface="AppleGothic"/>
+                        </a:rPr>
+                        <a:t>0.202</a:t>
+                      </a:r>
+                    </a:p>
+                  </a:txBody>
+                  <a:tcPr anchor="ctr">
+                    <a:solidFill>
+                      <a:srgbClr val="F2F2F0"/>
+                    </a:solidFill>
+                  </a:tcPr>
+                </a:tc>
+              </a:tr>
+              <a:tr h="211666">
+                <a:tc>
+                  <a:txBody>
+                    <a:bodyPr/>
+                    <a:lstStyle/>
+                    <a:p>
+                      <a:pPr algn="l"/>
+                      <a:r>
+                        <a:rPr sz="900" b="1">
+                          <a:solidFill>
+                            <a:srgbClr val="111111"/>
+                          </a:solidFill>
+                          <a:latin typeface="AppleGothic"/>
+                          <a:ea typeface="AppleGothic"/>
+                        </a:rPr>
+                        <a:t>MATRb2</a:t>
+                      </a:r>
+                    </a:p>
+                  </a:txBody>
+                  <a:tcPr anchor="ctr">
+                    <a:solidFill>
+                      <a:srgbClr val="FFFFFF"/>
+                    </a:solidFill>
+                  </a:tcPr>
+                </a:tc>
+                <a:tc>
+                  <a:txBody>
+                    <a:bodyPr/>
+                    <a:lstStyle/>
+                    <a:p>
+                      <a:pPr algn="ctr"/>
+                      <a:r>
+                        <a:rPr sz="900" b="0">
+                          <a:solidFill>
+                            <a:srgbClr val="111111"/>
+                          </a:solidFill>
+                          <a:latin typeface="AppleGothic"/>
+                          <a:ea typeface="AppleGothic"/>
+                        </a:rPr>
+                        <a:t>0.862</a:t>
+                      </a:r>
+                    </a:p>
+                  </a:txBody>
+                  <a:tcPr anchor="ctr">
+                    <a:solidFill>
+                      <a:srgbClr val="FFFFFF"/>
+                    </a:solidFill>
+                  </a:tcPr>
+                </a:tc>
+                <a:tc>
+                  <a:txBody>
+                    <a:bodyPr/>
+                    <a:lstStyle/>
+                    <a:p>
+                      <a:pPr algn="l"/>
+                      <a:r>
+                        <a:rPr sz="900" b="0">
+                          <a:solidFill>
+                            <a:srgbClr val="111111"/>
+                          </a:solidFill>
+                          <a:latin typeface="AppleGothic"/>
+                          <a:ea typeface="AppleGothic"/>
+                        </a:rPr>
+                        <a:t>0.850</a:t>
+                      </a:r>
+                    </a:p>
+                  </a:txBody>
+                  <a:tcPr anchor="ctr">
+                    <a:solidFill>
+                      <a:srgbClr val="FFFFFF"/>
+                    </a:solidFill>
+                  </a:tcPr>
+                </a:tc>
+                <a:tc>
+                  <a:txBody>
+                    <a:bodyPr/>
+                    <a:lstStyle/>
+                    <a:p>
+                      <a:pPr algn="l"/>
+                      <a:r>
+                        <a:rPr sz="900" b="0">
+                          <a:solidFill>
+                            <a:srgbClr val="111111"/>
+                          </a:solidFill>
+                          <a:latin typeface="AppleGothic"/>
+                          <a:ea typeface="AppleGothic"/>
+                        </a:rPr>
+                        <a:t>0.777</a:t>
+                      </a:r>
+                    </a:p>
+                  </a:txBody>
+                  <a:tcPr anchor="ctr">
+                    <a:solidFill>
+                      <a:srgbClr val="FFFFFF"/>
+                    </a:solidFill>
+                  </a:tcPr>
+                </a:tc>
+                <a:tc>
+                  <a:txBody>
+                    <a:bodyPr/>
+                    <a:lstStyle/>
+                    <a:p>
+                      <a:pPr algn="ctr"/>
+                      <a:r>
+                        <a:rPr sz="900" b="0">
+                          <a:solidFill>
+                            <a:srgbClr val="111111"/>
+                          </a:solidFill>
+                          <a:latin typeface="AppleGothic"/>
+                          <a:ea typeface="AppleGothic"/>
+                        </a:rPr>
+                        <a:t>0.674</a:t>
+                      </a:r>
+                    </a:p>
+                  </a:txBody>
+                  <a:tcPr anchor="ctr">
+                    <a:solidFill>
+                      <a:srgbClr val="FFFFFF"/>
+                    </a:solidFill>
+                  </a:tcPr>
+                </a:tc>
+                <a:tc>
+                  <a:txBody>
+                    <a:bodyPr/>
+                    <a:lstStyle/>
+                    <a:p>
+                      <a:pPr algn="ctr"/>
+                      <a:r>
+                        <a:rPr sz="900" b="0">
+                          <a:solidFill>
+                            <a:srgbClr val="111111"/>
+                          </a:solidFill>
+                          <a:latin typeface="AppleGothic"/>
+                          <a:ea typeface="AppleGothic"/>
+                        </a:rPr>
+                        <a:t>-0.78</a:t>
+                      </a:r>
+                    </a:p>
+                  </a:txBody>
+                  <a:tcPr anchor="ctr">
+                    <a:solidFill>
+                      <a:srgbClr val="FFFFFF"/>
+                    </a:solidFill>
+                  </a:tcPr>
+                </a:tc>
+                <a:tc>
+                  <a:txBody>
+                    <a:bodyPr/>
+                    <a:lstStyle/>
+                    <a:p>
+                      <a:pPr algn="ctr"/>
+                      <a:r>
+                        <a:rPr sz="900" b="0">
+                          <a:solidFill>
+                            <a:srgbClr val="111111"/>
+                          </a:solidFill>
+                          <a:latin typeface="AppleGothic"/>
+                          <a:ea typeface="AppleGothic"/>
+                        </a:rPr>
+                        <a:t>0.739</a:t>
+                      </a:r>
+                    </a:p>
+                  </a:txBody>
+                  <a:tcPr anchor="ctr">
+                    <a:solidFill>
+                      <a:srgbClr val="FFFFFF"/>
+                    </a:solidFill>
+                  </a:tcPr>
+                </a:tc>
+                <a:tc>
+                  <a:txBody>
+                    <a:bodyPr/>
+                    <a:lstStyle/>
+                    <a:p>
+                      <a:pPr algn="ctr"/>
+                      <a:r>
+                        <a:rPr sz="900" b="0">
+                          <a:solidFill>
+                            <a:srgbClr val="111111"/>
+                          </a:solidFill>
+                          <a:latin typeface="AppleGothic"/>
+                          <a:ea typeface="AppleGothic"/>
+                        </a:rPr>
+                        <a:t>0.21</a:t>
+                      </a:r>
+                    </a:p>
+                  </a:txBody>
+                  <a:tcPr anchor="ctr">
+                    <a:solidFill>
+                      <a:srgbClr val="FFFFFF"/>
+                    </a:solidFill>
+                  </a:tcPr>
+                </a:tc>
+                <a:tc>
+                  <a:txBody>
+                    <a:bodyPr/>
+                    <a:lstStyle/>
+                    <a:p>
+                      <a:pPr algn="ctr"/>
+                      <a:r>
+                        <a:rPr sz="900" b="0">
+                          <a:solidFill>
+                            <a:srgbClr val="111111"/>
+                          </a:solidFill>
+                          <a:latin typeface="AppleGothic"/>
+                          <a:ea typeface="AppleGothic"/>
+                        </a:rPr>
+                        <a:t>0.618</a:t>
+                      </a:r>
+                    </a:p>
+                  </a:txBody>
+                  <a:tcPr anchor="ctr">
+                    <a:solidFill>
+                      <a:srgbClr val="FFFFFF"/>
+                    </a:solidFill>
+                  </a:tcPr>
+                </a:tc>
+              </a:tr>
+              <a:tr h="211672">
+                <a:tc>
+                  <a:txBody>
+                    <a:bodyPr/>
+                    <a:lstStyle/>
+                    <a:p>
+                      <a:pPr algn="l"/>
+                      <a:r>
+                        <a:rPr sz="900" b="1">
+                          <a:solidFill>
+                            <a:srgbClr val="111111"/>
+                          </a:solidFill>
+                          <a:latin typeface="AppleGothic"/>
+                          <a:ea typeface="AppleGothic"/>
+                        </a:rPr>
+                        <a:t>NCMAPSS</a:t>
+                      </a:r>
+                    </a:p>
+                  </a:txBody>
+                  <a:tcPr anchor="ctr">
+                    <a:solidFill>
+                      <a:srgbClr val="F2F2F0"/>
+                    </a:solidFill>
+                  </a:tcPr>
+                </a:tc>
+                <a:tc>
+                  <a:txBody>
+                    <a:bodyPr/>
+                    <a:lstStyle/>
+                    <a:p>
+                      <a:pPr algn="ctr"/>
+                      <a:r>
+                        <a:rPr sz="900" b="0">
+                          <a:solidFill>
+                            <a:srgbClr val="111111"/>
+                          </a:solidFill>
+                          <a:latin typeface="AppleGothic"/>
+                          <a:ea typeface="AppleGothic"/>
+                        </a:rPr>
+                        <a:t>0.937</a:t>
+                      </a:r>
+                    </a:p>
+                  </a:txBody>
+                  <a:tcPr anchor="ctr">
+                    <a:solidFill>
+                      <a:srgbClr val="F2F2F0"/>
+                    </a:solidFill>
+                  </a:tcPr>
+                </a:tc>
+                <a:tc>
+                  <a:txBody>
+                    <a:bodyPr/>
+                    <a:lstStyle/>
+                    <a:p>
+                      <a:pPr algn="l"/>
+                      <a:r>
+                        <a:rPr sz="900" b="0">
+                          <a:solidFill>
+                            <a:srgbClr val="111111"/>
+                          </a:solidFill>
+                          <a:latin typeface="AppleGothic"/>
+                          <a:ea typeface="AppleGothic"/>
+                        </a:rPr>
+                        <a:t>0.883</a:t>
+                      </a:r>
+                    </a:p>
+                  </a:txBody>
+                  <a:tcPr anchor="ctr">
+                    <a:solidFill>
+                      <a:srgbClr val="F2F2F0"/>
+                    </a:solidFill>
+                  </a:tcPr>
+                </a:tc>
+                <a:tc>
+                  <a:txBody>
+                    <a:bodyPr/>
+                    <a:lstStyle/>
+                    <a:p>
+                      <a:pPr algn="l"/>
+                      <a:r>
+                        <a:rPr sz="900" b="0">
+                          <a:solidFill>
+                            <a:srgbClr val="111111"/>
+                          </a:solidFill>
+                          <a:latin typeface="AppleGothic"/>
+                          <a:ea typeface="AppleGothic"/>
+                        </a:rPr>
+                        <a:t>0.880</a:t>
+                      </a:r>
+                    </a:p>
+                  </a:txBody>
+                  <a:tcPr anchor="ctr">
+                    <a:solidFill>
+                      <a:srgbClr val="F2F2F0"/>
+                    </a:solidFill>
+                  </a:tcPr>
+                </a:tc>
+                <a:tc>
+                  <a:txBody>
+                    <a:bodyPr/>
+                    <a:lstStyle/>
+                    <a:p>
+                      <a:pPr algn="ctr"/>
+                      <a:r>
+                        <a:rPr sz="900" b="0">
+                          <a:solidFill>
+                            <a:srgbClr val="111111"/>
+                          </a:solidFill>
+                          <a:latin typeface="AppleGothic"/>
+                          <a:ea typeface="AppleGothic"/>
+                        </a:rPr>
+                        <a:t>0.892</a:t>
+                      </a:r>
+                    </a:p>
+                  </a:txBody>
+                  <a:tcPr anchor="ctr">
+                    <a:solidFill>
+                      <a:srgbClr val="F2F2F0"/>
+                    </a:solidFill>
+                  </a:tcPr>
+                </a:tc>
+                <a:tc>
+                  <a:txBody>
+                    <a:bodyPr/>
+                    <a:lstStyle/>
+                    <a:p>
+                      <a:pPr algn="ctr"/>
+                      <a:r>
+                        <a:rPr sz="900" b="0">
+                          <a:solidFill>
+                            <a:srgbClr val="111111"/>
+                          </a:solidFill>
+                          <a:latin typeface="AppleGothic"/>
+                          <a:ea typeface="AppleGothic"/>
+                        </a:rPr>
+                        <a:t>0.819</a:t>
+                      </a:r>
+                    </a:p>
+                  </a:txBody>
+                  <a:tcPr anchor="ctr">
+                    <a:solidFill>
+                      <a:srgbClr val="F2F2F0"/>
+                    </a:solidFill>
+                  </a:tcPr>
+                </a:tc>
+                <a:tc>
+                  <a:txBody>
+                    <a:bodyPr/>
+                    <a:lstStyle/>
+                    <a:p>
+                      <a:pPr algn="ctr"/>
+                      <a:r>
+                        <a:rPr sz="900" b="0">
+                          <a:solidFill>
+                            <a:srgbClr val="111111"/>
+                          </a:solidFill>
+                          <a:latin typeface="AppleGothic"/>
+                          <a:ea typeface="AppleGothic"/>
+                        </a:rPr>
+                        <a:t>0.932</a:t>
+                      </a:r>
+                    </a:p>
+                  </a:txBody>
+                  <a:tcPr anchor="ctr">
+                    <a:solidFill>
+                      <a:srgbClr val="F2F2F0"/>
+                    </a:solidFill>
+                  </a:tcPr>
+                </a:tc>
+                <a:tc>
+                  <a:txBody>
+                    <a:bodyPr/>
+                    <a:lstStyle/>
+                    <a:p>
+                      <a:pPr algn="ctr"/>
+                      <a:r>
+                        <a:rPr sz="900" b="0">
+                          <a:solidFill>
+                            <a:srgbClr val="111111"/>
+                          </a:solidFill>
+                          <a:latin typeface="AppleGothic"/>
+                          <a:ea typeface="AppleGothic"/>
+                        </a:rPr>
+                        <a:t>0.80</a:t>
+                      </a:r>
+                    </a:p>
+                  </a:txBody>
+                  <a:tcPr anchor="ctr">
+                    <a:solidFill>
+                      <a:srgbClr val="F2F2F0"/>
+                    </a:solidFill>
+                  </a:tcPr>
+                </a:tc>
+                <a:tc>
+                  <a:txBody>
+                    <a:bodyPr/>
+                    <a:lstStyle/>
+                    <a:p>
+                      <a:pPr algn="ctr"/>
+                      <a:r>
+                        <a:rPr sz="900" b="0">
+                          <a:solidFill>
+                            <a:srgbClr val="111111"/>
+                          </a:solidFill>
+                          <a:latin typeface="AppleGothic"/>
+                          <a:ea typeface="AppleGothic"/>
+                        </a:rPr>
+                        <a:t>0.934</a:t>
+                      </a:r>
+                    </a:p>
+                  </a:txBody>
+                  <a:tcPr anchor="ctr">
+                    <a:solidFill>
+                      <a:srgbClr val="F2F2F0"/>
+                    </a:solidFill>
+                  </a:tcPr>
+                </a:tc>
+              </a:tr>
+            </a:tbl>
+          </a:graphicData>
+        </a:graphic>
+      </p:graphicFrame>
       <p:cxnSp>
         <p:nvCxnSpPr>
-          <p:cNvPr id="7" name="Connector 6"/>
+          <p:cNvPr id="8" name="Connector 7"/>
           <p:cNvCxnSpPr/>
           <p:nvPr/>
         </p:nvCxnSpPr>
@@ -8451,7 +10446,7 @@
       </p:cxnSp>
       <p:sp>
         <p:nvSpPr>
-          <p:cNvPr id="8" name="TextBox 7"/>
+          <p:cNvPr id="9" name="TextBox 8"/>
           <p:cNvSpPr txBox="1"/>
           <p:nvPr/>
         </p:nvSpPr>
@@ -8487,7 +10482,7 @@
       </p:sp>
       <p:sp>
         <p:nvSpPr>
-          <p:cNvPr id="9" name="TextBox 8"/>
+          <p:cNvPr id="10" name="TextBox 9"/>
           <p:cNvSpPr txBox="1"/>
           <p:nvPr/>
         </p:nvSpPr>

</xml_diff>

<commit_message>
Clarify PP-X contribution slides
Co-authored-by: Cursor <cursoragent@cursor.com>
</commit_message>
<xml_diff>
--- a/output/PP_Research_Detailed_v2.pptx
+++ b/output/PP_Research_Detailed_v2.pptx
@@ -24167,7 +24167,7 @@
                 <a:latin typeface="Arial"/>
                 <a:ea typeface="AppleGothic"/>
               </a:rPr>
-              <a:t>모델링 의도 · research gap</a:t>
+              <a:t>왜 PP-X가 필요한가</a:t>
             </a:r>
           </a:p>
         </p:txBody>
@@ -24203,7 +24203,7 @@
                 <a:latin typeface="Arial"/>
                 <a:ea typeface="AppleGothic"/>
               </a:rPr>
-              <a:t>외삽을 test-independent structural assumption approval 문제로 다시 정의한다</a:t>
+              <a:t>외삽에서는 예측기보다 먼저 구조 가정의 사용 자격을 검증해야 한다</a:t>
             </a:r>
           </a:p>
         </p:txBody>
@@ -24232,14 +24232,14 @@
           <a:p>
             <a:pPr algn="ctr"/>
             <a:r>
-              <a:rPr sz="1900" b="1">
+              <a:rPr sz="1800" b="1">
                 <a:solidFill>
                   <a:srgbClr val="0072B2"/>
                 </a:solidFill>
                 <a:latin typeface="Arial"/>
                 <a:ea typeface="AppleGothic"/>
               </a:rPr>
-              <a:t>PP-X treats extrapolation as test-independent approval/rejection of structural assumptions.</a:t>
+              <a:t>관측 범위 밖에서는 데이터만으로 답을 정할 수 없다. PP-X는 구조 가정을 사전 선언하고, 검증된 가정만 실행한다.</a:t>
             </a:r>
           </a:p>
         </p:txBody>
@@ -24665,14 +24665,14 @@
           <a:p>
             <a:pPr algn="ctr"/>
             <a:r>
-              <a:rPr sz="1400" b="1">
+              <a:rPr sz="1500" b="1">
                 <a:solidFill>
                   <a:srgbClr val="222222"/>
                 </a:solidFill>
                 <a:latin typeface="Arial"/>
                 <a:ea typeface="AppleGothic"/>
               </a:rPr>
-              <a:t>연구 gap은 affine+NN, hard boundary, gate 각각의 최초성이 아니다. typed admissibility + prior-centered residual authority + predeployment unit-risk approval/fallback을 하나의 실행 계약으로 결합하는 데 있다.</a:t>
+              <a:t>핵심 전환: test에서 잘 맞는 모델을 고르는 것이 아니라, test를 보기 전에 구조 가정의 사용 권한을 승인하거나 거절한다.</a:t>
             </a:r>
           </a:p>
         </p:txBody>
@@ -24708,7 +24708,7 @@
                 <a:latin typeface="Arial"/>
                 <a:ea typeface="AppleGothic"/>
               </a:rPr>
-              <a:t>목표: test sample별로 잘 맞는 모델을 고르는 것이 아니라, test를 보기 전에 구조 가정의 사용 권한을 승인하거나 거절한다.</a:t>
+              <a:t>PP-X = Declare assumptions → Learn constrained residual → Approve with validation evidence → Decline to fallback</a:t>
             </a:r>
           </a:p>
         </p:txBody>
@@ -30776,7 +30776,7 @@
                 <a:latin typeface="Arial"/>
                 <a:ea typeface="AppleGothic"/>
               </a:rPr>
-              <a:t>본 연구의 기여 3개 · evidence mapping</a:t>
+              <a:t>PP-X의 세 가지 기여</a:t>
             </a:r>
           </a:p>
         </p:txBody>
@@ -30812,7 +30812,7 @@
                 <a:latin typeface="Arial"/>
                 <a:ea typeface="AppleGothic"/>
               </a:rPr>
-              <a:t>각 기여는 지지 증거와 반례를 함께 제시한다</a:t>
+              <a:t>가정을 선언하고 · prior의 권한을 보존하며 · 근거가 없으면 실행하지 않는다</a:t>
             </a:r>
           </a:p>
         </p:txBody>
@@ -31184,7 +31184,7 @@
                 <a:latin typeface="Arial"/>
                 <a:ea typeface="AppleGothic"/>
               </a:rPr>
-              <a:t>기여의 단위는 ‘새 부품’이 아니라 선언–권한–승인–거절이 연결된 실행 규율이다.</a:t>
+              <a:t>핵심 기여는 새 부품 하나가 아니라, 외삽 가정을 통제하는 선언–학습–승인–거절의 end-to-end 규율이다.</a:t>
             </a:r>
           </a:p>
         </p:txBody>
@@ -31431,7 +31431,7 @@
                 <a:latin typeface="Arial"/>
                 <a:ea typeface="AppleGothic"/>
               </a:rPr>
-              <a:t>Novelty positioning matrix</a:t>
+              <a:t>무엇이 새로운가</a:t>
             </a:r>
           </a:p>
         </p:txBody>
@@ -31467,7 +31467,7 @@
                 <a:latin typeface="Arial"/>
                 <a:ea typeface="AppleGothic"/>
               </a:rPr>
-              <a:t>인접 방법과의 차이를 좁고 방어 가능하게 진술한다</a:t>
+              <a:t>새 prior나 gate 자체가 아니라 네 요소를 하나의 검증 가능한 실행 계약으로 결합했다</a:t>
             </a:r>
           </a:p>
         </p:txBody>
@@ -32119,7 +32119,7 @@
                 <a:latin typeface="Arial"/>
                 <a:ea typeface="AppleGothic"/>
               </a:rPr>
-              <a:t>Novelty claim: typed admissibility + prior-centered residual authority + predeployment unit-risk approval/fallback의 결합.</a:t>
+              <a:t>Novelty = typed contract + frozen-prior residual authority + validation-only approval + exact fallback/abstention.</a:t>
             </a:r>
           </a:p>
         </p:txBody>
@@ -32366,7 +32366,7 @@
                 <a:latin typeface="Arial"/>
                 <a:ea typeface="AppleGothic"/>
               </a:rPr>
-              <a:t>Claim–evidence–limitation · reviewer defense</a:t>
+              <a:t>어디까지 주장할 수 있는가</a:t>
             </a:r>
           </a:p>
         </p:txBody>
@@ -32402,7 +32402,7 @@
                 <a:latin typeface="Arial"/>
                 <a:ea typeface="AppleGothic"/>
               </a:rPr>
-              <a:t>세 evidence tier를 합치지 않고 투고 주장을 제한한다</a:t>
+              <a:t>회고적 우세 · 동일예산 재검증 · prospective 결과를 분리해 과장을 막는다</a:t>
             </a:r>
           </a:p>
         </p:txBody>
@@ -32915,7 +32915,7 @@
                 <a:latin typeface="Arial"/>
                 <a:ea typeface="AppleGothic"/>
               </a:rPr>
-              <a:t>투고 bottleneck: 독립 prospective predictive superiority 1개 추가 필요. 현재는 route-selection validity와 retrospective breadth를 주장하고, prospective superiority는 주장하지 않는다.</a:t>
+              <a:t>현재 결론: PP-X의 구조적 필요성과 회고적 일관성은 지지된다. 다만 독립 prospective 예측 우월성은 아직 확증되지 않았다.</a:t>
             </a:r>
           </a:p>
         </p:txBody>

</xml_diff>

<commit_message>
Polish PP-X presentation language
Co-authored-by: Cursor <cursoragent@cursor.com>
</commit_message>
<xml_diff>
--- a/output/PP_Research_Detailed_v2.pptx
+++ b/output/PP_Research_Detailed_v2.pptx
@@ -23745,7 +23745,7 @@
                 <a:latin typeface="Arial"/>
                 <a:ea typeface="AppleGothic"/>
               </a:rPr>
-              <a:t>관측 범위 밖에서는 데이터만으로 답을 정할 수 없다. PP-X는 구조 가정을 사전 선언하고, 검증된 가정만 실행한다.</a:t>
+              <a:t>관측 범위를 벗어나면 데이터만으로 예측 곡선의 형태를 정하기 어렵다. 따라서 어떤 구조 가정을 사용할지 먼저 판단해야 한다.</a:t>
             </a:r>
           </a:p>
         </p:txBody>
@@ -24218,7 +24218,7 @@
                 <a:latin typeface="Arial"/>
                 <a:ea typeface="AppleGothic"/>
               </a:rPr>
-              <a:t>핵심 전환  test에서 잘 맞는 모델을 고르는 것이 아니라, test를 보기 전에 구조 가정의 사용 권한을 승인하거나 거절한다.</a:t>
+              <a:t>PP-X는 시험 결과를 보고 유리한 모델을 고르지 않는다. 학습과 검증 단계에서 사용할 가정과 실행 경로를 정하고, 시험 단계에서는 이를 그대로 적용한다.</a:t>
             </a:r>
           </a:p>
         </p:txBody>
@@ -24254,7 +24254,7 @@
                 <a:latin typeface="Arial"/>
                 <a:ea typeface="AppleGothic"/>
               </a:rPr>
-              <a:t>PP-X = Declare assumptions → Learn constrained residual → Approve with validation evidence → Decline to fallback</a:t>
+              <a:t>가정 선언  ·  제한된 residual 학습  ·  검증자료 기반 승인  ·  미승인 시 대체 경로 적용</a:t>
             </a:r>
           </a:p>
         </p:txBody>
@@ -31635,7 +31635,7 @@
                 <a:latin typeface="Arial"/>
                 <a:ea typeface="AppleGothic"/>
               </a:rPr>
-              <a:t>PP-X의 세 가지 기여</a:t>
+              <a:t>본 연구의 기여</a:t>
             </a:r>
           </a:p>
         </p:txBody>
@@ -31671,7 +31671,7 @@
                 <a:latin typeface="Arial"/>
                 <a:ea typeface="AppleGothic"/>
               </a:rPr>
-              <a:t>가정을 선언하고 · prior의 권한을 보존하며 · 근거가 없으면 실행하지 않는다</a:t>
+              <a:t>PP-X는 구조 가정의 선언, 학습 범위, 승인 기준을 하나의 절차로 정리한다</a:t>
             </a:r>
           </a:p>
         </p:txBody>
@@ -32556,7 +32556,7 @@
                 <a:latin typeface="Arial"/>
                 <a:ea typeface="AppleGothic"/>
               </a:rPr>
-              <a:t>연구 기여 = 새 부품 하나가 아니라, 외삽 가정을 통제하는 선언–학습–승인–거절의 end-to-end 규율</a:t>
+              <a:t>개별 모듈보다 중요한 기여는 구조 가정의 선언부터 승인 또는 거절까지를 재현 가능한 절차로 정식화했다는 점이다.</a:t>
             </a:r>
           </a:p>
         </p:txBody>
@@ -32803,7 +32803,7 @@
                 <a:latin typeface="Arial"/>
                 <a:ea typeface="AppleGothic"/>
               </a:rPr>
-              <a:t>무엇이 새로운가</a:t>
+              <a:t>기존 방법과의 차이</a:t>
             </a:r>
           </a:p>
         </p:txBody>
@@ -32839,7 +32839,7 @@
                 <a:latin typeface="Arial"/>
                 <a:ea typeface="AppleGothic"/>
               </a:rPr>
-              <a:t>새 prior나 gate 자체가 아니라 네 요소를 하나의 검증 가능한 실행 계약으로 결합했다</a:t>
+              <a:t>구조 가정의 허용 범위와 승인 절차를 명시했다는 점에서 기존 방법과 구분된다</a:t>
             </a:r>
           </a:p>
         </p:txBody>
@@ -32915,14 +32915,14 @@
           <a:p>
             <a:pPr algn="ctr"/>
             <a:r>
-              <a:rPr sz="1700" b="1">
+              <a:rPr sz="1600" b="1">
                 <a:solidFill>
                   <a:srgbClr val="0072B2"/>
                 </a:solidFill>
                 <a:latin typeface="Arial"/>
                 <a:ea typeface="AppleGothic"/>
               </a:rPr>
-              <a:t>Typed contract  +  frozen-prior residual authority  +  validation-only approval  +  exact fallback</a:t>
+              <a:t>Typed contract · frozen prior 주변의 residual 학습 · validation-only 승인 · 사전 지정 fallback</a:t>
             </a:r>
           </a:p>
         </p:txBody>
@@ -33778,7 +33778,7 @@
                 <a:latin typeface="Arial"/>
                 <a:ea typeface="AppleGothic"/>
               </a:rPr>
-              <a:t>주장하지 않음  최초의 physics hybrid · 최초의 affine+NN · 새로운 MoE gate · universal/literature SOTA</a:t>
+              <a:t>개별 모듈의 최초성이나 모든 외삽 문제에서의 우월성은 주장하지 않는다.</a:t>
             </a:r>
           </a:p>
         </p:txBody>
@@ -34025,7 +34025,7 @@
                 <a:latin typeface="Arial"/>
                 <a:ea typeface="AppleGothic"/>
               </a:rPr>
-              <a:t>어디까지 주장할 수 있는가</a:t>
+              <a:t>결과의 해석 범위</a:t>
             </a:r>
           </a:p>
         </p:txBody>
@@ -34061,7 +34061,7 @@
                 <a:latin typeface="Arial"/>
                 <a:ea typeface="AppleGothic"/>
               </a:rPr>
-              <a:t>회고적 우세 · 동일예산 재검증 · prospective 결과를 분리해 과장을 막는다</a:t>
+              <a:t>회고 분석, 동일예산 재검증, prospective 평가를 구분해 해석한다</a:t>
             </a:r>
           </a:p>
         </p:txBody>
@@ -34924,7 +34924,7 @@
                 <a:latin typeface="Arial"/>
                 <a:ea typeface="AppleGothic"/>
               </a:rPr>
-              <a:t>현재 결론  PP-X의 구조적 필요성과 회고적 일관성은 지지된다. 독립 prospective 예측 우월성은 아직 확증되지 않았다.</a:t>
+              <a:t>PP-X의 구조적 필요성과 회고 분석에서의 일관성은 확인되었다. 다만 독립 prospective 평가에서의 예측 우월성은 아직 확증되지 않았다.</a:t>
             </a:r>
           </a:p>
         </p:txBody>
@@ -34960,7 +34960,7 @@
                 <a:latin typeface="Arial"/>
                 <a:ea typeface="AppleGothic"/>
               </a:rPr>
-              <a:t>금지: universal/literature SOTA · safety guarantee · 최초의 hybrid/PINN · prospective superiority.</a:t>
+              <a:t>논문의 주장 범위: strict-tail 외삽에서의 구조 검증과 조건부 실행. 보편적 SOTA나 안전 보장은 포함하지 않는다.</a:t>
             </a:r>
           </a:p>
         </p:txBody>
@@ -37088,7 +37088,7 @@
                 <a:latin typeface="Arial"/>
                 <a:ea typeface="AppleGothic"/>
               </a:rPr>
-              <a:t>PP-X 한눈에 보기</a:t>
+              <a:t>PP-X 개요</a:t>
             </a:r>
           </a:p>
         </p:txBody>
@@ -37124,7 +37124,7 @@
                 <a:latin typeface="Arial"/>
                 <a:ea typeface="AppleGothic"/>
               </a:rPr>
-              <a:t>검증이 허용한 구조 가정만 사용하고, 허용되지 않으면 사전 고정 경로로 돌아간다</a:t>
+              <a:t>검증자료가 지지하는 구조만 사용하고, 그렇지 않으면 미리 정한 대체 경로를 적용한다</a:t>
             </a:r>
           </a:p>
         </p:txBody>
@@ -37231,7 +37231,7 @@
                 <a:latin typeface="Arial"/>
                 <a:ea typeface="AppleGothic"/>
               </a:rPr>
-              <a:t>한 줄 정의  PP-X는 test sample을 보고 expert를 고르는 모델이 아니다. 배포 전에 typed contract를 선언하고, validation evidence로 executor의 사용 권한을 동결하는 외삽 프레임워크다.</a:t>
+              <a:t>PP-X는 시험 표본마다 모델을 바꾸지 않는다. 학습 전에 구조 가정과 대체 경로를 선언하고, 검증자료로 사용할 실행 구조를 결정한 뒤 시험 단계에서는 이를 고정한다.</a:t>
             </a:r>
           </a:p>
         </p:txBody>
@@ -37267,7 +37267,7 @@
                 <a:latin typeface="Arial"/>
                 <a:ea typeface="AppleGothic"/>
               </a:rPr>
-              <a:t>출력: approved executor의 예측  |  승인 실패: exact frozen fallback 또는 abstention</a:t>
+              <a:t>승인된 경우 해당 executor를 사용하고, 승인되지 않으면 사전 지정 fallback을 사용하거나 예측을 보류한다.</a:t>
             </a:r>
           </a:p>
         </p:txBody>

</xml_diff>